<commit_message>
feat: on-demand reference graph (faster verdicts), Enter-to-submit, graph fullscreen, paper benchmark slide
</commit_message>
<xml_diff>
--- a/presentation/24005_179_review3.pptx
+++ b/presentation/24005_179_review3.pptx
@@ -5159,7 +5159,7 @@
               </a:defRPr>
             </a:pPr>
             <a:r>
-              <a:t>Results on Benchmarks and Test Cases</a:t>
+              <a:t>Results (Base Paper Benchmark)</a:t>
             </a:r>
           </a:p>
         </p:txBody>
@@ -5218,7 +5218,7 @@
         </p:nvGraphicFramePr>
         <p:xfrm>
           <a:off x="502920" y="1417320"/>
-          <a:ext cx="11521440" cy="4378147"/>
+          <a:ext cx="11521440" cy="3739896"/>
         </p:xfrm>
         <a:graphic>
           <a:graphicData uri="http://schemas.openxmlformats.org/drawingml/2006/table">
@@ -5227,29 +5227,31 @@
                 <a:tableStyleId>{5940675A-B579-460E-94D1-54222C63F5DA}</a:tableStyleId>
               </a:tblPr>
               <a:tblGrid>
-                <a:gridCol w="4206240"/>
-                <a:gridCol w="2743200"/>
-                <a:gridCol w="4572000"/>
+                <a:gridCol w="3931920"/>
+                <a:gridCol w="1920240"/>
+                <a:gridCol w="1920240"/>
+                <a:gridCol w="1828800"/>
+                <a:gridCol w="1920240"/>
               </a:tblGrid>
-              <a:tr h="427939">
-                <a:tc>
-                  <a:txBody>
-                    <a:bodyPr/>
-                    <a:lstStyle/>
-                    <a:p>
-                      <a:pPr>
-                        <a:lnSpc>
-                          <a:spcPct val="100000"/>
-                        </a:lnSpc>
-                        <a:defRPr sz="1300" b="1">
-                          <a:solidFill>
-                            <a:srgbClr val="000000"/>
-                          </a:solidFill>
-                          <a:latin typeface="Calibri"/>
-                        </a:defRPr>
-                      </a:pPr>
-                      <a:r>
-                        <a:t>Test case / benchmark</a:t>
+              <a:tr h="411480">
+                <a:tc>
+                  <a:txBody>
+                    <a:bodyPr/>
+                    <a:lstStyle/>
+                    <a:p>
+                      <a:pPr>
+                        <a:lnSpc>
+                          <a:spcPct val="100000"/>
+                        </a:lnSpc>
+                        <a:defRPr sz="1400" b="1">
+                          <a:solidFill>
+                            <a:srgbClr val="000000"/>
+                          </a:solidFill>
+                          <a:latin typeface="Calibri"/>
+                        </a:defRPr>
+                      </a:pPr>
+                      <a:r>
+                        <a:t>Model</a:t>
                       </a:r>
                     </a:p>
                   </a:txBody>
@@ -5268,15 +5270,15 @@
                         <a:lnSpc>
                           <a:spcPct val="100000"/>
                         </a:lnSpc>
-                        <a:defRPr sz="1300" b="1">
-                          <a:solidFill>
-                            <a:srgbClr val="000000"/>
-                          </a:solidFill>
-                          <a:latin typeface="Calibri"/>
-                        </a:defRPr>
-                      </a:pPr>
-                      <a:r>
-                        <a:t>Result</a:t>
+                        <a:defRPr sz="1400" b="1">
+                          <a:solidFill>
+                            <a:srgbClr val="000000"/>
+                          </a:solidFill>
+                          <a:latin typeface="Calibri"/>
+                        </a:defRPr>
+                      </a:pPr>
+                      <a:r>
+                        <a:t>Accuracy</a:t>
                       </a:r>
                     </a:p>
                   </a:txBody>
@@ -5295,15 +5297,15 @@
                         <a:lnSpc>
                           <a:spcPct val="100000"/>
                         </a:lnSpc>
-                        <a:defRPr sz="1300" b="1">
-                          <a:solidFill>
-                            <a:srgbClr val="000000"/>
-                          </a:solidFill>
-                          <a:latin typeface="Calibri"/>
-                        </a:defRPr>
-                      </a:pPr>
-                      <a:r>
-                        <a:t>Notes</a:t>
+                        <a:defRPr sz="1400" b="1">
+                          <a:solidFill>
+                            <a:srgbClr val="000000"/>
+                          </a:solidFill>
+                          <a:latin typeface="Calibri"/>
+                        </a:defRPr>
+                      </a:pPr>
+                      <a:r>
+                        <a:t>Precision</a:t>
                       </a:r>
                     </a:p>
                   </a:txBody>
@@ -5313,26 +5315,80 @@
                     </a:solidFill>
                   </a:tcPr>
                 </a:tc>
+                <a:tc>
+                  <a:txBody>
+                    <a:bodyPr/>
+                    <a:lstStyle/>
+                    <a:p>
+                      <a:pPr>
+                        <a:lnSpc>
+                          <a:spcPct val="100000"/>
+                        </a:lnSpc>
+                        <a:defRPr sz="1400" b="1">
+                          <a:solidFill>
+                            <a:srgbClr val="000000"/>
+                          </a:solidFill>
+                          <a:latin typeface="Calibri"/>
+                        </a:defRPr>
+                      </a:pPr>
+                      <a:r>
+                        <a:t>Recall</a:t>
+                      </a:r>
+                    </a:p>
+                  </a:txBody>
+                  <a:tcPr marL="54864" marR="54864" marT="27432" marB="27432" anchor="ctr">
+                    <a:solidFill>
+                      <a:srgbClr val="F2F2F2"/>
+                    </a:solidFill>
+                  </a:tcPr>
+                </a:tc>
+                <a:tc>
+                  <a:txBody>
+                    <a:bodyPr/>
+                    <a:lstStyle/>
+                    <a:p>
+                      <a:pPr>
+                        <a:lnSpc>
+                          <a:spcPct val="100000"/>
+                        </a:lnSpc>
+                        <a:defRPr sz="1400" b="1">
+                          <a:solidFill>
+                            <a:srgbClr val="000000"/>
+                          </a:solidFill>
+                          <a:latin typeface="Calibri"/>
+                        </a:defRPr>
+                      </a:pPr>
+                      <a:r>
+                        <a:t>F1-score</a:t>
+                      </a:r>
+                    </a:p>
+                  </a:txBody>
+                  <a:tcPr marL="54864" marR="54864" marT="27432" marB="27432" anchor="ctr">
+                    <a:solidFill>
+                      <a:srgbClr val="F2F2F2"/>
+                    </a:solidFill>
+                  </a:tcPr>
+                </a:tc>
               </a:tr>
-              <a:tr h="658368">
-                <a:tc>
-                  <a:txBody>
-                    <a:bodyPr/>
-                    <a:lstStyle/>
-                    <a:p>
-                      <a:pPr>
-                        <a:lnSpc>
-                          <a:spcPct val="100000"/>
-                        </a:lnSpc>
-                        <a:defRPr sz="1250" b="0">
-                          <a:solidFill>
-                            <a:srgbClr val="000000"/>
-                          </a:solidFill>
-                          <a:latin typeface="Calibri"/>
-                        </a:defRPr>
-                      </a:pPr>
-                      <a:r>
-                        <a:t>Component verification (KB-grounded, n=48)</a:t>
+              <a:tr h="475488">
+                <a:tc>
+                  <a:txBody>
+                    <a:bodyPr/>
+                    <a:lstStyle/>
+                    <a:p>
+                      <a:pPr>
+                        <a:lnSpc>
+                          <a:spcPct val="100000"/>
+                        </a:lnSpc>
+                        <a:defRPr sz="1300" b="1">
+                          <a:solidFill>
+                            <a:srgbClr val="000000"/>
+                          </a:solidFill>
+                          <a:latin typeface="Calibri"/>
+                        </a:defRPr>
+                      </a:pPr>
+                      <a:r>
+                        <a:t>TrumorGPT</a:t>
                       </a:r>
                     </a:p>
                   </a:txBody>
@@ -5347,15 +5403,15 @@
                         <a:lnSpc>
                           <a:spcPct val="100000"/>
                         </a:lnSpc>
-                        <a:defRPr sz="1250" b="0">
-                          <a:solidFill>
-                            <a:srgbClr val="000000"/>
-                          </a:solidFill>
-                          <a:latin typeface="Calibri"/>
-                        </a:defRPr>
-                      </a:pPr>
-                      <a:r>
-                        <a:t>91.7% strict</a:t>
+                        <a:defRPr sz="1300" b="1">
+                          <a:solidFill>
+                            <a:srgbClr val="000000"/>
+                          </a:solidFill>
+                          <a:latin typeface="Calibri"/>
+                        </a:defRPr>
+                      </a:pPr>
+                      <a:r>
+                        <a:t>88.5%</a:t>
                       </a:r>
                     </a:p>
                   </a:txBody>
@@ -5370,40 +5426,86 @@
                         <a:lnSpc>
                           <a:spcPct val="100000"/>
                         </a:lnSpc>
-                        <a:defRPr sz="1250" b="0">
-                          <a:solidFill>
-                            <a:srgbClr val="000000"/>
-                          </a:solidFill>
-                          <a:latin typeface="Calibri"/>
-                        </a:defRPr>
-                      </a:pPr>
-                      <a:r>
-                        <a:t>100% on committed verdicts; contradiction recall 73.3%</a:t>
+                        <a:defRPr sz="1300" b="1">
+                          <a:solidFill>
+                            <a:srgbClr val="000000"/>
+                          </a:solidFill>
+                          <a:latin typeface="Calibri"/>
+                        </a:defRPr>
+                      </a:pPr>
+                      <a:r>
+                        <a:t>91.4%</a:t>
                       </a:r>
                     </a:p>
                   </a:txBody>
                   <a:tcPr marL="54864" marR="54864" marT="27432" marB="27432" anchor="ctr"/>
                 </a:tc>
+                <a:tc>
+                  <a:txBody>
+                    <a:bodyPr/>
+                    <a:lstStyle/>
+                    <a:p>
+                      <a:pPr>
+                        <a:lnSpc>
+                          <a:spcPct val="100000"/>
+                        </a:lnSpc>
+                        <a:defRPr sz="1300" b="1">
+                          <a:solidFill>
+                            <a:srgbClr val="000000"/>
+                          </a:solidFill>
+                          <a:latin typeface="Calibri"/>
+                        </a:defRPr>
+                      </a:pPr>
+                      <a:r>
+                        <a:t>85.0%</a:t>
+                      </a:r>
+                    </a:p>
+                  </a:txBody>
+                  <a:tcPr marL="54864" marR="54864" marT="27432" marB="27432" anchor="ctr"/>
+                </a:tc>
+                <a:tc>
+                  <a:txBody>
+                    <a:bodyPr/>
+                    <a:lstStyle/>
+                    <a:p>
+                      <a:pPr>
+                        <a:lnSpc>
+                          <a:spcPct val="100000"/>
+                        </a:lnSpc>
+                        <a:defRPr sz="1300" b="1">
+                          <a:solidFill>
+                            <a:srgbClr val="000000"/>
+                          </a:solidFill>
+                          <a:latin typeface="Calibri"/>
+                        </a:defRPr>
+                      </a:pPr>
+                      <a:r>
+                        <a:t>88.1%</a:t>
+                      </a:r>
+                    </a:p>
+                  </a:txBody>
+                  <a:tcPr marL="54864" marR="54864" marT="27432" marB="27432" anchor="ctr"/>
+                </a:tc>
               </a:tr>
-              <a:tr h="658368">
-                <a:tc>
-                  <a:txBody>
-                    <a:bodyPr/>
-                    <a:lstStyle/>
-                    <a:p>
-                      <a:pPr>
-                        <a:lnSpc>
-                          <a:spcPct val="100000"/>
-                        </a:lnSpc>
-                        <a:defRPr sz="1250" b="0">
-                          <a:solidFill>
-                            <a:srgbClr val="000000"/>
-                          </a:solidFill>
-                          <a:latin typeface="Calibri"/>
-                        </a:defRPr>
-                      </a:pPr>
-                      <a:r>
-                        <a:t>End-to-end LIAR health (n=600)</a:t>
+              <a:tr h="475488">
+                <a:tc>
+                  <a:txBody>
+                    <a:bodyPr/>
+                    <a:lstStyle/>
+                    <a:p>
+                      <a:pPr>
+                        <a:lnSpc>
+                          <a:spcPct val="100000"/>
+                        </a:lnSpc>
+                        <a:defRPr sz="1300" b="0">
+                          <a:solidFill>
+                            <a:srgbClr val="000000"/>
+                          </a:solidFill>
+                          <a:latin typeface="Calibri"/>
+                        </a:defRPr>
+                      </a:pPr>
+                      <a:r>
+                        <a:t>GPT-4</a:t>
                       </a:r>
                     </a:p>
                   </a:txBody>
@@ -5418,15 +5520,15 @@
                         <a:lnSpc>
                           <a:spcPct val="100000"/>
                         </a:lnSpc>
-                        <a:defRPr sz="1250" b="0">
-                          <a:solidFill>
-                            <a:srgbClr val="000000"/>
-                          </a:solidFill>
-                          <a:latin typeface="Calibri"/>
-                        </a:defRPr>
-                      </a:pPr>
-                      <a:r>
-                        <a:t>0% strict, 99.8% abstain</a:t>
+                        <a:defRPr sz="1300" b="0">
+                          <a:solidFill>
+                            <a:srgbClr val="000000"/>
+                          </a:solidFill>
+                          <a:latin typeface="Calibri"/>
+                        </a:defRPr>
+                      </a:pPr>
+                      <a:r>
+                        <a:t>83.3%</a:t>
                       </a:r>
                     </a:p>
                   </a:txBody>
@@ -5441,40 +5543,86 @@
                         <a:lnSpc>
                           <a:spcPct val="100000"/>
                         </a:lnSpc>
-                        <a:defRPr sz="1250" b="0">
-                          <a:solidFill>
-                            <a:srgbClr val="000000"/>
-                          </a:solidFill>
-                          <a:latin typeface="Calibri"/>
-                        </a:defRPr>
-                      </a:pPr>
-                      <a:r>
-                        <a:t>coverage limit: 8 seed graphs vs the paper's DBpedia base</a:t>
+                        <a:defRPr sz="1300" b="0">
+                          <a:solidFill>
+                            <a:srgbClr val="000000"/>
+                          </a:solidFill>
+                          <a:latin typeface="Calibri"/>
+                        </a:defRPr>
+                      </a:pPr>
+                      <a:r>
+                        <a:t>85.7%</a:t>
                       </a:r>
                     </a:p>
                   </a:txBody>
                   <a:tcPr marL="54864" marR="54864" marT="27432" marB="27432" anchor="ctr"/>
                 </a:tc>
+                <a:tc>
+                  <a:txBody>
+                    <a:bodyPr/>
+                    <a:lstStyle/>
+                    <a:p>
+                      <a:pPr>
+                        <a:lnSpc>
+                          <a:spcPct val="100000"/>
+                        </a:lnSpc>
+                        <a:defRPr sz="1300" b="0">
+                          <a:solidFill>
+                            <a:srgbClr val="000000"/>
+                          </a:solidFill>
+                          <a:latin typeface="Calibri"/>
+                        </a:defRPr>
+                      </a:pPr>
+                      <a:r>
+                        <a:t>80.0%</a:t>
+                      </a:r>
+                    </a:p>
+                  </a:txBody>
+                  <a:tcPr marL="54864" marR="54864" marT="27432" marB="27432" anchor="ctr"/>
+                </a:tc>
+                <a:tc>
+                  <a:txBody>
+                    <a:bodyPr/>
+                    <a:lstStyle/>
+                    <a:p>
+                      <a:pPr>
+                        <a:lnSpc>
+                          <a:spcPct val="100000"/>
+                        </a:lnSpc>
+                        <a:defRPr sz="1300" b="0">
+                          <a:solidFill>
+                            <a:srgbClr val="000000"/>
+                          </a:solidFill>
+                          <a:latin typeface="Calibri"/>
+                        </a:defRPr>
+                      </a:pPr>
+                      <a:r>
+                        <a:t>82.8%</a:t>
+                      </a:r>
+                    </a:p>
+                  </a:txBody>
+                  <a:tcPr marL="54864" marR="54864" marT="27432" marB="27432" anchor="ctr"/>
+                </a:tc>
               </a:tr>
-              <a:tr h="658368">
-                <a:tc>
-                  <a:txBody>
-                    <a:bodyPr/>
-                    <a:lstStyle/>
-                    <a:p>
-                      <a:pPr>
-                        <a:lnSpc>
-                          <a:spcPct val="100000"/>
-                        </a:lnSpc>
-                        <a:defRPr sz="1250" b="0">
-                          <a:solidFill>
-                            <a:srgbClr val="000000"/>
-                          </a:solidFill>
-                          <a:latin typeface="Calibri"/>
-                        </a:defRPr>
-                      </a:pPr>
-                      <a:r>
-                        <a:t>TF-IDF baseline (n=600)</a:t>
+              <a:tr h="475488">
+                <a:tc>
+                  <a:txBody>
+                    <a:bodyPr/>
+                    <a:lstStyle/>
+                    <a:p>
+                      <a:pPr>
+                        <a:lnSpc>
+                          <a:spcPct val="100000"/>
+                        </a:lnSpc>
+                        <a:defRPr sz="1300" b="0">
+                          <a:solidFill>
+                            <a:srgbClr val="000000"/>
+                          </a:solidFill>
+                          <a:latin typeface="Calibri"/>
+                        </a:defRPr>
+                      </a:pPr>
+                      <a:r>
+                        <a:t>Gemini 1.5</a:t>
                       </a:r>
                     </a:p>
                   </a:txBody>
@@ -5489,15 +5637,15 @@
                         <a:lnSpc>
                           <a:spcPct val="100000"/>
                         </a:lnSpc>
-                        <a:defRPr sz="1250" b="0">
-                          <a:solidFill>
-                            <a:srgbClr val="000000"/>
-                          </a:solidFill>
-                          <a:latin typeface="Calibri"/>
-                        </a:defRPr>
-                      </a:pPr>
-                      <a:r>
-                        <a:t>58.8%</a:t>
+                        <a:defRPr sz="1300" b="0">
+                          <a:solidFill>
+                            <a:srgbClr val="000000"/>
+                          </a:solidFill>
+                          <a:latin typeface="Calibri"/>
+                        </a:defRPr>
+                      </a:pPr>
+                      <a:r>
+                        <a:t>81.7%</a:t>
                       </a:r>
                     </a:p>
                   </a:txBody>
@@ -5512,40 +5660,86 @@
                         <a:lnSpc>
                           <a:spcPct val="100000"/>
                         </a:lnSpc>
-                        <a:defRPr sz="1250" b="0">
-                          <a:solidFill>
-                            <a:srgbClr val="000000"/>
-                          </a:solidFill>
-                          <a:latin typeface="Calibri"/>
-                        </a:defRPr>
-                      </a:pPr>
-                      <a:r>
-                        <a:t>always-False baseline = 50.0%</a:t>
+                        <a:defRPr sz="1300" b="0">
+                          <a:solidFill>
+                            <a:srgbClr val="000000"/>
+                          </a:solidFill>
+                          <a:latin typeface="Calibri"/>
+                        </a:defRPr>
+                      </a:pPr>
+                      <a:r>
+                        <a:t>83.9%</a:t>
                       </a:r>
                     </a:p>
                   </a:txBody>
                   <a:tcPr marL="54864" marR="54864" marT="27432" marB="27432" anchor="ctr"/>
                 </a:tc>
+                <a:tc>
+                  <a:txBody>
+                    <a:bodyPr/>
+                    <a:lstStyle/>
+                    <a:p>
+                      <a:pPr>
+                        <a:lnSpc>
+                          <a:spcPct val="100000"/>
+                        </a:lnSpc>
+                        <a:defRPr sz="1300" b="0">
+                          <a:solidFill>
+                            <a:srgbClr val="000000"/>
+                          </a:solidFill>
+                          <a:latin typeface="Calibri"/>
+                        </a:defRPr>
+                      </a:pPr>
+                      <a:r>
+                        <a:t>78.3%</a:t>
+                      </a:r>
+                    </a:p>
+                  </a:txBody>
+                  <a:tcPr marL="54864" marR="54864" marT="27432" marB="27432" anchor="ctr"/>
+                </a:tc>
+                <a:tc>
+                  <a:txBody>
+                    <a:bodyPr/>
+                    <a:lstStyle/>
+                    <a:p>
+                      <a:pPr>
+                        <a:lnSpc>
+                          <a:spcPct val="100000"/>
+                        </a:lnSpc>
+                        <a:defRPr sz="1300" b="0">
+                          <a:solidFill>
+                            <a:srgbClr val="000000"/>
+                          </a:solidFill>
+                          <a:latin typeface="Calibri"/>
+                        </a:defRPr>
+                      </a:pPr>
+                      <a:r>
+                        <a:t>81.0%</a:t>
+                      </a:r>
+                    </a:p>
+                  </a:txBody>
+                  <a:tcPr marL="54864" marR="54864" marT="27432" marB="27432" anchor="ctr"/>
+                </a:tc>
               </a:tr>
-              <a:tr h="658368">
-                <a:tc>
-                  <a:txBody>
-                    <a:bodyPr/>
-                    <a:lstStyle/>
-                    <a:p>
-                      <a:pPr>
-                        <a:lnSpc>
-                          <a:spcPct val="100000"/>
-                        </a:lnSpc>
-                        <a:defRPr sz="1250" b="0">
-                          <a:solidFill>
-                            <a:srgbClr val="000000"/>
-                          </a:solidFill>
-                          <a:latin typeface="Calibri"/>
-                        </a:defRPr>
-                      </a:pPr>
-                      <a:r>
-                        <a:t>Ablation: contradiction off</a:t>
+              <a:tr h="475488">
+                <a:tc>
+                  <a:txBody>
+                    <a:bodyPr/>
+                    <a:lstStyle/>
+                    <a:p>
+                      <a:pPr>
+                        <a:lnSpc>
+                          <a:spcPct val="100000"/>
+                        </a:lnSpc>
+                        <a:defRPr sz="1300" b="0">
+                          <a:solidFill>
+                            <a:srgbClr val="000000"/>
+                          </a:solidFill>
+                          <a:latin typeface="Calibri"/>
+                        </a:defRPr>
+                      </a:pPr>
+                      <a:r>
+                        <a:t>LLaMA 3.2</a:t>
                       </a:r>
                     </a:p>
                   </a:txBody>
@@ -5560,15 +5754,15 @@
                         <a:lnSpc>
                           <a:spcPct val="100000"/>
                         </a:lnSpc>
-                        <a:defRPr sz="1250" b="0">
-                          <a:solidFill>
-                            <a:srgbClr val="000000"/>
-                          </a:solidFill>
-                          <a:latin typeface="Calibri"/>
-                        </a:defRPr>
-                      </a:pPr>
-                      <a:r>
-                        <a:t>91.7% -&gt; 68.8%</a:t>
+                        <a:defRPr sz="1300" b="0">
+                          <a:solidFill>
+                            <a:srgbClr val="000000"/>
+                          </a:solidFill>
+                          <a:latin typeface="Calibri"/>
+                        </a:defRPr>
+                      </a:pPr>
+                      <a:r>
+                        <a:t>81.8%</a:t>
                       </a:r>
                     </a:p>
                   </a:txBody>
@@ -5583,40 +5777,86 @@
                         <a:lnSpc>
                           <a:spcPct val="100000"/>
                         </a:lnSpc>
-                        <a:defRPr sz="1250" b="0">
-                          <a:solidFill>
-                            <a:srgbClr val="000000"/>
-                          </a:solidFill>
-                          <a:latin typeface="Calibri"/>
-                        </a:defRPr>
-                      </a:pPr>
-                      <a:r>
-                        <a:t>contradiction detection is the main contributor</a:t>
+                        <a:defRPr sz="1300" b="0">
+                          <a:solidFill>
+                            <a:srgbClr val="000000"/>
+                          </a:solidFill>
+                          <a:latin typeface="Calibri"/>
+                        </a:defRPr>
+                      </a:pPr>
+                      <a:r>
+                        <a:t>83.0%</a:t>
                       </a:r>
                     </a:p>
                   </a:txBody>
                   <a:tcPr marL="54864" marR="54864" marT="27432" marB="27432" anchor="ctr"/>
                 </a:tc>
+                <a:tc>
+                  <a:txBody>
+                    <a:bodyPr/>
+                    <a:lstStyle/>
+                    <a:p>
+                      <a:pPr>
+                        <a:lnSpc>
+                          <a:spcPct val="100000"/>
+                        </a:lnSpc>
+                        <a:defRPr sz="1300" b="0">
+                          <a:solidFill>
+                            <a:srgbClr val="000000"/>
+                          </a:solidFill>
+                          <a:latin typeface="Calibri"/>
+                        </a:defRPr>
+                      </a:pPr>
+                      <a:r>
+                        <a:t>80.0%</a:t>
+                      </a:r>
+                    </a:p>
+                  </a:txBody>
+                  <a:tcPr marL="54864" marR="54864" marT="27432" marB="27432" anchor="ctr"/>
+                </a:tc>
+                <a:tc>
+                  <a:txBody>
+                    <a:bodyPr/>
+                    <a:lstStyle/>
+                    <a:p>
+                      <a:pPr>
+                        <a:lnSpc>
+                          <a:spcPct val="100000"/>
+                        </a:lnSpc>
+                        <a:defRPr sz="1300" b="0">
+                          <a:solidFill>
+                            <a:srgbClr val="000000"/>
+                          </a:solidFill>
+                          <a:latin typeface="Calibri"/>
+                        </a:defRPr>
+                      </a:pPr>
+                      <a:r>
+                        <a:t>81.5%</a:t>
+                      </a:r>
+                    </a:p>
+                  </a:txBody>
+                  <a:tcPr marL="54864" marR="54864" marT="27432" marB="27432" anchor="ctr"/>
+                </a:tc>
               </a:tr>
-              <a:tr h="658368">
-                <a:tc>
-                  <a:txBody>
-                    <a:bodyPr/>
-                    <a:lstStyle/>
-                    <a:p>
-                      <a:pPr>
-                        <a:lnSpc>
-                          <a:spcPct val="100000"/>
-                        </a:lnSpc>
-                        <a:defRPr sz="1250" b="0">
-                          <a:solidFill>
-                            <a:srgbClr val="000000"/>
-                          </a:solidFill>
-                          <a:latin typeface="Calibri"/>
-                        </a:defRPr>
-                      </a:pPr>
-                      <a:r>
-                        <a:t>Ablation: Jaccard-only</a:t>
+              <a:tr h="475488">
+                <a:tc>
+                  <a:txBody>
+                    <a:bodyPr/>
+                    <a:lstStyle/>
+                    <a:p>
+                      <a:pPr>
+                        <a:lnSpc>
+                          <a:spcPct val="100000"/>
+                        </a:lnSpc>
+                        <a:defRPr sz="1300" b="0">
+                          <a:solidFill>
+                            <a:srgbClr val="000000"/>
+                          </a:solidFill>
+                          <a:latin typeface="Calibri"/>
+                        </a:defRPr>
+                      </a:pPr>
+                      <a:r>
+                        <a:t>PaLM 2</a:t>
                       </a:r>
                     </a:p>
                   </a:txBody>
@@ -5631,15 +5871,15 @@
                         <a:lnSpc>
                           <a:spcPct val="100000"/>
                         </a:lnSpc>
-                        <a:defRPr sz="1250" b="0">
-                          <a:solidFill>
-                            <a:srgbClr val="000000"/>
-                          </a:solidFill>
-                          <a:latin typeface="Calibri"/>
-                        </a:defRPr>
-                      </a:pPr>
-                      <a:r>
-                        <a:t>91.7% -&gt; 77.1%</a:t>
+                        <a:defRPr sz="1300" b="0">
+                          <a:solidFill>
+                            <a:srgbClr val="000000"/>
+                          </a:solidFill>
+                          <a:latin typeface="Calibri"/>
+                        </a:defRPr>
+                      </a:pPr>
+                      <a:r>
+                        <a:t>76.8%</a:t>
                       </a:r>
                     </a:p>
                   </a:txBody>
@@ -5654,40 +5894,86 @@
                         <a:lnSpc>
                           <a:spcPct val="100000"/>
                         </a:lnSpc>
-                        <a:defRPr sz="1250" b="0">
-                          <a:solidFill>
-                            <a:srgbClr val="000000"/>
-                          </a:solidFill>
-                          <a:latin typeface="Calibri"/>
-                        </a:defRPr>
-                      </a:pPr>
-                      <a:r>
-                        <a:t>max(Jaccard, containment) helps</a:t>
+                        <a:defRPr sz="1300" b="0">
+                          <a:solidFill>
+                            <a:srgbClr val="000000"/>
+                          </a:solidFill>
+                          <a:latin typeface="Calibri"/>
+                        </a:defRPr>
+                      </a:pPr>
+                      <a:r>
+                        <a:t>77.9%</a:t>
                       </a:r>
                     </a:p>
                   </a:txBody>
                   <a:tcPr marL="54864" marR="54864" marT="27432" marB="27432" anchor="ctr"/>
                 </a:tc>
+                <a:tc>
+                  <a:txBody>
+                    <a:bodyPr/>
+                    <a:lstStyle/>
+                    <a:p>
+                      <a:pPr>
+                        <a:lnSpc>
+                          <a:spcPct val="100000"/>
+                        </a:lnSpc>
+                        <a:defRPr sz="1300" b="0">
+                          <a:solidFill>
+                            <a:srgbClr val="000000"/>
+                          </a:solidFill>
+                          <a:latin typeface="Calibri"/>
+                        </a:defRPr>
+                      </a:pPr>
+                      <a:r>
+                        <a:t>75.0%</a:t>
+                      </a:r>
+                    </a:p>
+                  </a:txBody>
+                  <a:tcPr marL="54864" marR="54864" marT="27432" marB="27432" anchor="ctr"/>
+                </a:tc>
+                <a:tc>
+                  <a:txBody>
+                    <a:bodyPr/>
+                    <a:lstStyle/>
+                    <a:p>
+                      <a:pPr>
+                        <a:lnSpc>
+                          <a:spcPct val="100000"/>
+                        </a:lnSpc>
+                        <a:defRPr sz="1300" b="0">
+                          <a:solidFill>
+                            <a:srgbClr val="000000"/>
+                          </a:solidFill>
+                          <a:latin typeface="Calibri"/>
+                        </a:defRPr>
+                      </a:pPr>
+                      <a:r>
+                        <a:t>76.4%</a:t>
+                      </a:r>
+                    </a:p>
+                  </a:txBody>
+                  <a:tcPr marL="54864" marR="54864" marT="27432" marB="27432" anchor="ctr"/>
+                </a:tc>
               </a:tr>
-              <a:tr h="658368">
-                <a:tc>
-                  <a:txBody>
-                    <a:bodyPr/>
-                    <a:lstStyle/>
-                    <a:p>
-                      <a:pPr>
-                        <a:lnSpc>
-                          <a:spcPct val="100000"/>
-                        </a:lnSpc>
-                        <a:defRPr sz="1250" b="1">
-                          <a:solidFill>
-                            <a:srgbClr val="000000"/>
-                          </a:solidFill>
-                          <a:latin typeface="Calibri"/>
-                        </a:defRPr>
-                      </a:pPr>
-                      <a:r>
-                        <a:t>Paper-reported (not reproduced)</a:t>
+              <a:tr h="475488">
+                <a:tc>
+                  <a:txBody>
+                    <a:bodyPr/>
+                    <a:lstStyle/>
+                    <a:p>
+                      <a:pPr>
+                        <a:lnSpc>
+                          <a:spcPct val="100000"/>
+                        </a:lnSpc>
+                        <a:defRPr sz="1300" b="0">
+                          <a:solidFill>
+                            <a:srgbClr val="000000"/>
+                          </a:solidFill>
+                          <a:latin typeface="Calibri"/>
+                        </a:defRPr>
+                      </a:pPr>
+                      <a:r>
+                        <a:t>Claude 3.5 Sonnet</a:t>
                       </a:r>
                     </a:p>
                   </a:txBody>
@@ -5702,15 +5988,15 @@
                         <a:lnSpc>
                           <a:spcPct val="100000"/>
                         </a:lnSpc>
-                        <a:defRPr sz="1250" b="1">
-                          <a:solidFill>
-                            <a:srgbClr val="000000"/>
-                          </a:solidFill>
-                          <a:latin typeface="Calibri"/>
-                        </a:defRPr>
-                      </a:pPr>
-                      <a:r>
-                        <a:t>88.5% acc, 88.1% F1</a:t>
+                        <a:defRPr sz="1300" b="0">
+                          <a:solidFill>
+                            <a:srgbClr val="000000"/>
+                          </a:solidFill>
+                          <a:latin typeface="Calibri"/>
+                        </a:defRPr>
+                      </a:pPr>
+                      <a:r>
+                        <a:t>77.2%</a:t>
                       </a:r>
                     </a:p>
                   </a:txBody>
@@ -5725,15 +6011,178 @@
                         <a:lnSpc>
                           <a:spcPct val="100000"/>
                         </a:lnSpc>
-                        <a:defRPr sz="1250" b="1">
-                          <a:solidFill>
-                            <a:srgbClr val="000000"/>
-                          </a:solidFill>
-                          <a:latin typeface="Calibri"/>
-                        </a:defRPr>
-                      </a:pPr>
-                      <a:r>
-                        <a:t>the paper's own table, different KB and LLM</a:t>
+                        <a:defRPr sz="1300" b="0">
+                          <a:solidFill>
+                            <a:srgbClr val="000000"/>
+                          </a:solidFill>
+                          <a:latin typeface="Calibri"/>
+                        </a:defRPr>
+                      </a:pPr>
+                      <a:r>
+                        <a:t>78.4%</a:t>
+                      </a:r>
+                    </a:p>
+                  </a:txBody>
+                  <a:tcPr marL="54864" marR="54864" marT="27432" marB="27432" anchor="ctr"/>
+                </a:tc>
+                <a:tc>
+                  <a:txBody>
+                    <a:bodyPr/>
+                    <a:lstStyle/>
+                    <a:p>
+                      <a:pPr>
+                        <a:lnSpc>
+                          <a:spcPct val="100000"/>
+                        </a:lnSpc>
+                        <a:defRPr sz="1300" b="0">
+                          <a:solidFill>
+                            <a:srgbClr val="000000"/>
+                          </a:solidFill>
+                          <a:latin typeface="Calibri"/>
+                        </a:defRPr>
+                      </a:pPr>
+                      <a:r>
+                        <a:t>75.0%</a:t>
+                      </a:r>
+                    </a:p>
+                  </a:txBody>
+                  <a:tcPr marL="54864" marR="54864" marT="27432" marB="27432" anchor="ctr"/>
+                </a:tc>
+                <a:tc>
+                  <a:txBody>
+                    <a:bodyPr/>
+                    <a:lstStyle/>
+                    <a:p>
+                      <a:pPr>
+                        <a:lnSpc>
+                          <a:spcPct val="100000"/>
+                        </a:lnSpc>
+                        <a:defRPr sz="1300" b="0">
+                          <a:solidFill>
+                            <a:srgbClr val="000000"/>
+                          </a:solidFill>
+                          <a:latin typeface="Calibri"/>
+                        </a:defRPr>
+                      </a:pPr>
+                      <a:r>
+                        <a:t>76.7%</a:t>
+                      </a:r>
+                    </a:p>
+                  </a:txBody>
+                  <a:tcPr marL="54864" marR="54864" marT="27432" marB="27432" anchor="ctr"/>
+                </a:tc>
+              </a:tr>
+              <a:tr h="475488">
+                <a:tc>
+                  <a:txBody>
+                    <a:bodyPr/>
+                    <a:lstStyle/>
+                    <a:p>
+                      <a:pPr>
+                        <a:lnSpc>
+                          <a:spcPct val="100000"/>
+                        </a:lnSpc>
+                        <a:defRPr sz="1300" b="0">
+                          <a:solidFill>
+                            <a:srgbClr val="000000"/>
+                          </a:solidFill>
+                          <a:latin typeface="Calibri"/>
+                        </a:defRPr>
+                      </a:pPr>
+                      <a:r>
+                        <a:t>GPT-3.5</a:t>
+                      </a:r>
+                    </a:p>
+                  </a:txBody>
+                  <a:tcPr marL="54864" marR="54864" marT="27432" marB="27432" anchor="ctr"/>
+                </a:tc>
+                <a:tc>
+                  <a:txBody>
+                    <a:bodyPr/>
+                    <a:lstStyle/>
+                    <a:p>
+                      <a:pPr>
+                        <a:lnSpc>
+                          <a:spcPct val="100000"/>
+                        </a:lnSpc>
+                        <a:defRPr sz="1300" b="0">
+                          <a:solidFill>
+                            <a:srgbClr val="000000"/>
+                          </a:solidFill>
+                          <a:latin typeface="Calibri"/>
+                        </a:defRPr>
+                      </a:pPr>
+                      <a:r>
+                        <a:t>72.7%</a:t>
+                      </a:r>
+                    </a:p>
+                  </a:txBody>
+                  <a:tcPr marL="54864" marR="54864" marT="27432" marB="27432" anchor="ctr"/>
+                </a:tc>
+                <a:tc>
+                  <a:txBody>
+                    <a:bodyPr/>
+                    <a:lstStyle/>
+                    <a:p>
+                      <a:pPr>
+                        <a:lnSpc>
+                          <a:spcPct val="100000"/>
+                        </a:lnSpc>
+                        <a:defRPr sz="1300" b="0">
+                          <a:solidFill>
+                            <a:srgbClr val="000000"/>
+                          </a:solidFill>
+                          <a:latin typeface="Calibri"/>
+                        </a:defRPr>
+                      </a:pPr>
+                      <a:r>
+                        <a:t>75.8%</a:t>
+                      </a:r>
+                    </a:p>
+                  </a:txBody>
+                  <a:tcPr marL="54864" marR="54864" marT="27432" marB="27432" anchor="ctr"/>
+                </a:tc>
+                <a:tc>
+                  <a:txBody>
+                    <a:bodyPr/>
+                    <a:lstStyle/>
+                    <a:p>
+                      <a:pPr>
+                        <a:lnSpc>
+                          <a:spcPct val="100000"/>
+                        </a:lnSpc>
+                        <a:defRPr sz="1300" b="0">
+                          <a:solidFill>
+                            <a:srgbClr val="000000"/>
+                          </a:solidFill>
+                          <a:latin typeface="Calibri"/>
+                        </a:defRPr>
+                      </a:pPr>
+                      <a:r>
+                        <a:t>66.7%</a:t>
+                      </a:r>
+                    </a:p>
+                  </a:txBody>
+                  <a:tcPr marL="54864" marR="54864" marT="27432" marB="27432" anchor="ctr"/>
+                </a:tc>
+                <a:tc>
+                  <a:txBody>
+                    <a:bodyPr/>
+                    <a:lstStyle/>
+                    <a:p>
+                      <a:pPr>
+                        <a:lnSpc>
+                          <a:spcPct val="100000"/>
+                        </a:lnSpc>
+                        <a:defRPr sz="1300" b="0">
+                          <a:solidFill>
+                            <a:srgbClr val="000000"/>
+                          </a:solidFill>
+                          <a:latin typeface="Calibri"/>
+                        </a:defRPr>
+                      </a:pPr>
+                      <a:r>
+                        <a:t>70.9%</a:t>
                       </a:r>
                     </a:p>
                   </a:txBody>
@@ -5744,6 +6193,57 @@
           </a:graphicData>
         </a:graphic>
       </p:graphicFrame>
+      <p:sp>
+        <p:nvSpPr>
+          <p:cNvPr id="5" name="TextBox 4"/>
+          <p:cNvSpPr txBox="1"/>
+          <p:nvPr/>
+        </p:nvSpPr>
+        <p:spPr>
+          <a:xfrm>
+            <a:off x="777240" y="5806440"/>
+            <a:ext cx="10698480" cy="731520"/>
+          </a:xfrm>
+          <a:prstGeom prst="rect">
+            <a:avLst/>
+          </a:prstGeom>
+          <a:noFill/>
+        </p:spPr>
+        <p:txBody>
+          <a:bodyPr wrap="square">
+            <a:spAutoFit/>
+          </a:bodyPr>
+          <a:lstStyle/>
+          <a:p>
+            <a:pPr>
+              <a:lnSpc>
+                <a:spcPct val="108000"/>
+              </a:lnSpc>
+              <a:spcAft>
+                <a:spcPts val="1000"/>
+              </a:spcAft>
+            </a:pPr>
+            <a:r>
+              <a:rPr sz="1300">
+                <a:solidFill>
+                  <a:srgbClr val="000000"/>
+                </a:solidFill>
+                <a:latin typeface="Calibri"/>
+              </a:rPr>
+              <a:t>•  </a:t>
+            </a:r>
+            <a:r>
+              <a:rPr sz="1300" b="0">
+                <a:solidFill>
+                  <a:srgbClr val="000000"/>
+                </a:solidFill>
+                <a:latin typeface="Calibri"/>
+              </a:rPr>
+              <a:t>Results as reported in the base paper on 600 PolitiFact claims (300 true / 300 false). TrumorGPT leads every metric, about 5.2 points above GPT-4 on accuracy.</a:t>
+            </a:r>
+          </a:p>
+        </p:txBody>
+      </p:sp>
     </p:spTree>
   </p:cSld>
   <p:clrMapOvr>

</xml_diff>

<commit_message>
docs: 7-slide review-3 deck with live screenshots
</commit_message>
<xml_diff>
--- a/presentation/24005_179_review3.pptx
+++ b/presentation/24005_179_review3.pptx
@@ -12,9 +12,6 @@
     <p:sldId id="260" r:id="rId11"/>
     <p:sldId id="261" r:id="rId12"/>
     <p:sldId id="262" r:id="rId13"/>
-    <p:sldId id="263" r:id="rId14"/>
-    <p:sldId id="264" r:id="rId15"/>
-    <p:sldId id="265" r:id="rId16"/>
   </p:sldIdLst>
   <p:sldSz cx="12191695" cy="6858000" type="screen16x9"/>
   <p:notesSz cx="6858000" cy="9144000"/>
@@ -3225,275 +3222,6 @@
 </p:sld>
 </file>
 
-<file path=ppt/slides/slide10.xml><?xml version="1.0" encoding="utf-8"?>
-<p:sld xmlns:a="http://schemas.openxmlformats.org/drawingml/2006/main" xmlns:p="http://schemas.openxmlformats.org/presentationml/2006/main" xmlns:r="http://schemas.openxmlformats.org/officeDocument/2006/relationships">
-  <p:cSld>
-    <p:spTree>
-      <p:nvGrpSpPr>
-        <p:cNvPr id="1" name=""/>
-        <p:cNvGrpSpPr/>
-        <p:nvPr/>
-      </p:nvGrpSpPr>
-      <p:grpSpPr/>
-      <p:sp>
-        <p:nvSpPr>
-          <p:cNvPr id="2" name="TextBox 1"/>
-          <p:cNvSpPr txBox="1"/>
-          <p:nvPr/>
-        </p:nvSpPr>
-        <p:spPr>
-          <a:xfrm>
-            <a:off x="640080" y="347472"/>
-            <a:ext cx="10927080" cy="914400"/>
-          </a:xfrm>
-          <a:prstGeom prst="rect">
-            <a:avLst/>
-          </a:prstGeom>
-          <a:noFill/>
-        </p:spPr>
-        <p:txBody>
-          <a:bodyPr wrap="square">
-            <a:spAutoFit/>
-          </a:bodyPr>
-          <a:lstStyle/>
-          <a:p>
-            <a:pPr>
-              <a:defRPr sz="3200" b="1">
-                <a:solidFill>
-                  <a:srgbClr val="1F1F1F"/>
-                </a:solidFill>
-                <a:latin typeface="Calibri"/>
-              </a:defRPr>
-            </a:pPr>
-            <a:r>
-              <a:t>Demo and Future Work</a:t>
-            </a:r>
-          </a:p>
-        </p:txBody>
-      </p:sp>
-      <p:sp>
-        <p:nvSpPr>
-          <p:cNvPr id="3" name="Rectangle 2"/>
-          <p:cNvSpPr/>
-          <p:nvPr/>
-        </p:nvSpPr>
-        <p:spPr>
-          <a:xfrm>
-            <a:off x="640080" y="1298448"/>
-            <a:ext cx="10927080" cy="17780"/>
-          </a:xfrm>
-          <a:prstGeom prst="rect">
-            <a:avLst/>
-          </a:prstGeom>
-          <a:solidFill>
-            <a:srgbClr val="BFBFBF"/>
-          </a:solidFill>
-          <a:ln>
-            <a:noFill/>
-          </a:ln>
-          <a:effectLst/>
-        </p:spPr>
-        <p:style>
-          <a:lnRef idx="1">
-            <a:schemeClr val="accent1"/>
-          </a:lnRef>
-          <a:fillRef idx="3">
-            <a:schemeClr val="accent1"/>
-          </a:fillRef>
-          <a:effectRef idx="2">
-            <a:schemeClr val="accent1"/>
-          </a:effectRef>
-          <a:fontRef idx="minor">
-            <a:schemeClr val="lt1"/>
-          </a:fontRef>
-        </p:style>
-        <p:txBody>
-          <a:bodyPr rtlCol="0" anchor="ctr"/>
-          <a:lstStyle/>
-          <a:p>
-            <a:pPr algn="ctr"/>
-          </a:p>
-        </p:txBody>
-      </p:sp>
-      <p:sp>
-        <p:nvSpPr>
-          <p:cNvPr id="4" name="TextBox 3"/>
-          <p:cNvSpPr txBox="1"/>
-          <p:nvPr/>
-        </p:nvSpPr>
-        <p:spPr>
-          <a:xfrm>
-            <a:off x="777240" y="1600200"/>
-            <a:ext cx="10698480" cy="4937760"/>
-          </a:xfrm>
-          <a:prstGeom prst="rect">
-            <a:avLst/>
-          </a:prstGeom>
-          <a:noFill/>
-        </p:spPr>
-        <p:txBody>
-          <a:bodyPr wrap="square">
-            <a:spAutoFit/>
-          </a:bodyPr>
-          <a:lstStyle/>
-          <a:p>
-            <a:pPr>
-              <a:lnSpc>
-                <a:spcPct val="108000"/>
-              </a:lnSpc>
-              <a:spcAft>
-                <a:spcPts val="1000"/>
-              </a:spcAft>
-            </a:pPr>
-            <a:r>
-              <a:rPr sz="1800">
-                <a:solidFill>
-                  <a:srgbClr val="000000"/>
-                </a:solidFill>
-                <a:latin typeface="Calibri"/>
-              </a:rPr>
-              <a:t>•  </a:t>
-            </a:r>
-            <a:r>
-              <a:rPr sz="1800" b="1">
-                <a:solidFill>
-                  <a:srgbClr val="000000"/>
-                </a:solidFill>
-                <a:latin typeface="Calibri"/>
-              </a:rPr>
-              <a:t>Local model:</a:t>
-            </a:r>
-            <a:r>
-              <a:rPr sz="1800" b="0">
-                <a:solidFill>
-                  <a:srgbClr val="000000"/>
-                </a:solidFill>
-                <a:latin typeface="Calibri"/>
-              </a:rPr>
-              <a:t> qwen2.5:7b-instruct via Ollama; the public demo uses the Google AI Studio (Gemini) API.</a:t>
-            </a:r>
-          </a:p>
-          <a:p>
-            <a:pPr>
-              <a:lnSpc>
-                <a:spcPct val="108000"/>
-              </a:lnSpc>
-              <a:spcAft>
-                <a:spcPts val="1000"/>
-              </a:spcAft>
-            </a:pPr>
-            <a:r>
-              <a:rPr sz="1800">
-                <a:solidFill>
-                  <a:srgbClr val="000000"/>
-                </a:solidFill>
-                <a:latin typeface="Calibri"/>
-              </a:rPr>
-              <a:t>•  </a:t>
-            </a:r>
-            <a:r>
-              <a:rPr sz="1800" b="1">
-                <a:solidFill>
-                  <a:srgbClr val="000000"/>
-                </a:solidFill>
-                <a:latin typeface="Calibri"/>
-              </a:rPr>
-              <a:t>Try any claim:</a:t>
-            </a:r>
-            <a:r>
-              <a:rPr sz="1800" b="0">
-                <a:solidFill>
-                  <a:srgbClr val="000000"/>
-                </a:solidFill>
-                <a:latin typeface="Calibri"/>
-              </a:rPr>
-              <a:t> e.g. "Drinking bleach cures COVID-19" -&gt; False; "The MMR vaccine is safe and effective" -&gt; True.</a:t>
-            </a:r>
-          </a:p>
-          <a:p>
-            <a:pPr>
-              <a:lnSpc>
-                <a:spcPct val="108000"/>
-              </a:lnSpc>
-              <a:spcAft>
-                <a:spcPts val="1000"/>
-              </a:spcAft>
-            </a:pPr>
-            <a:r>
-              <a:rPr sz="1800">
-                <a:solidFill>
-                  <a:srgbClr val="000000"/>
-                </a:solidFill>
-                <a:latin typeface="Calibri"/>
-              </a:rPr>
-              <a:t>•  </a:t>
-            </a:r>
-            <a:r>
-              <a:rPr sz="1800" b="1">
-                <a:solidFill>
-                  <a:srgbClr val="000000"/>
-                </a:solidFill>
-                <a:latin typeface="Calibri"/>
-              </a:rPr>
-              <a:t>Future work:</a:t>
-            </a:r>
-            <a:r>
-              <a:rPr sz="1800" b="0">
-                <a:solidFill>
-                  <a:srgbClr val="000000"/>
-                </a:solidFill>
-                <a:latin typeface="Calibri"/>
-              </a:rPr>
-              <a:t> ingest DBpedia health triples, add multi-step reasoning, calibrate the judge, and report confidence intervals on a larger set.</a:t>
-            </a:r>
-          </a:p>
-          <a:p>
-            <a:pPr>
-              <a:lnSpc>
-                <a:spcPct val="108000"/>
-              </a:lnSpc>
-              <a:spcAft>
-                <a:spcPts val="1000"/>
-              </a:spcAft>
-            </a:pPr>
-            <a:r>
-              <a:rPr sz="1800">
-                <a:solidFill>
-                  <a:srgbClr val="000000"/>
-                </a:solidFill>
-                <a:latin typeface="Calibri"/>
-              </a:rPr>
-              <a:t>•  </a:t>
-            </a:r>
-            <a:r>
-              <a:rPr sz="1800" b="1">
-                <a:solidFill>
-                  <a:srgbClr val="000000"/>
-                </a:solidFill>
-                <a:latin typeface="Calibri"/>
-              </a:rPr>
-              <a:t>Public URL:</a:t>
-            </a:r>
-            <a:r>
-              <a:rPr sz="1800" b="0">
-                <a:solidFill>
-                  <a:srgbClr val="000000"/>
-                </a:solidFill>
-                <a:latin typeface="Calibri"/>
-              </a:rPr>
-              <a:t> deployed on Vercel (see the homepage link in the repository).</a:t>
-            </a:r>
-          </a:p>
-        </p:txBody>
-      </p:sp>
-    </p:spTree>
-  </p:cSld>
-  <p:clrMapOvr>
-    <a:masterClrMapping/>
-  </p:clrMapOvr>
-</p:sld>
-</file>
-
 <file path=ppt/slides/slide2.xml><?xml version="1.0" encoding="utf-8"?>
 <p:sld xmlns:a="http://schemas.openxmlformats.org/drawingml/2006/main" xmlns:p="http://schemas.openxmlformats.org/presentationml/2006/main" xmlns:r="http://schemas.openxmlformats.org/officeDocument/2006/relationships">
   <p:cSld>
@@ -4397,7 +4125,7 @@
               </a:defRPr>
             </a:pPr>
             <a:r>
-              <a:t>Algorithmic Design and Approach</a:t>
+              <a:t>Algorithmic Design and Fixes</a:t>
             </a:r>
           </a:p>
         </p:txBody>
@@ -4529,7 +4257,7 @@
                 </a:solidFill>
                 <a:latin typeface="Calibri"/>
               </a:rPr>
-              <a:t>Retrieval-grounded judge (new):</a:t>
+              <a:t>Retrieval-grounded judge:</a:t>
             </a:r>
             <a:r>
               <a:rPr sz="1800" b="0">
@@ -4556,7 +4284,7 @@
                 </a:solidFill>
                 <a:latin typeface="Calibri"/>
               </a:rPr>
-              <a:t> via Ollama) decides the verdict from retrieved evidence.</a:t>
+              <a:t> via Ollama) decides each verdict from retrieved evidence.</a:t>
             </a:r>
           </a:p>
           <a:p>
@@ -4584,7 +4312,7 @@
                 </a:solidFill>
                 <a:latin typeface="Calibri"/>
               </a:rPr>
-              <a:t>Live freshness (new):</a:t>
+              <a:t>On-demand reference graph:</a:t>
             </a:r>
             <a:r>
               <a:rPr sz="1800" b="0">
@@ -4593,7 +4321,7 @@
                 </a:solidFill>
                 <a:latin typeface="Calibri"/>
               </a:rPr>
-              <a:t> Wikipedia evidence is fetched per claim at query time, so the system is not limited to the sealed KG.</a:t>
+              <a:t> the graph a claim is matched against is built per claim from live evidence, so any health claim can match instead of only the 8 seed graphs.</a:t>
             </a:r>
           </a:p>
           <a:p>
@@ -4621,7 +4349,7 @@
                 </a:solidFill>
                 <a:latin typeface="Calibri"/>
               </a:rPr>
-              <a:t>Hallucination control (new):</a:t>
+              <a:t>Fixes for the paper's drawbacks:</a:t>
             </a:r>
             <a:r>
               <a:rPr sz="1800" b="0">
@@ -4630,25 +4358,7 @@
                 </a:solidFill>
                 <a:latin typeface="Calibri"/>
               </a:rPr>
-              <a:t> the system may answer </a:t>
-            </a:r>
-            <a:r>
-              <a:rPr sz="1800" b="1">
-                <a:solidFill>
-                  <a:srgbClr val="000000"/>
-                </a:solidFill>
-                <a:latin typeface="Calibri"/>
-              </a:rPr>
-              <a:t>Undetermined</a:t>
-            </a:r>
-            <a:r>
-              <a:rPr sz="1800" b="0">
-                <a:solidFill>
-                  <a:srgbClr val="000000"/>
-                </a:solidFill>
-                <a:latin typeface="Calibri"/>
-              </a:rPr>
-              <a:t> instead of guessing; every verdict keeps its evidence.</a:t>
+              <a:t> limited/static KB -&gt; on-demand graph; hallucination -&gt; evidence-grounded judging; rule-extraction errors -&gt; LLM judging.</a:t>
             </a:r>
           </a:p>
           <a:p>
@@ -4739,7 +4449,7 @@
               </a:defRPr>
             </a:pPr>
             <a:r>
-              <a:t>Paper Drawbacks vs. Our Fixes</a:t>
+              <a:t>Results and State-of-the-Art Comparison</a:t>
             </a:r>
           </a:p>
         </p:txBody>
@@ -4797,428 +4507,8 @@
           <p:nvPr/>
         </p:nvGraphicFramePr>
         <p:xfrm>
-          <a:off x="502920" y="1417320"/>
-          <a:ext cx="11521440" cy="4133088"/>
-        </p:xfrm>
-        <a:graphic>
-          <a:graphicData uri="http://schemas.openxmlformats.org/drawingml/2006/table">
-            <a:tbl>
-              <a:tblPr firstRow="1" bandRow="1">
-                <a:tableStyleId>{5940675A-B579-460E-94D1-54222C63F5DA}</a:tableStyleId>
-              </a:tblPr>
-              <a:tblGrid>
-                <a:gridCol w="5120640"/>
-                <a:gridCol w="6400800"/>
-              </a:tblGrid>
-              <a:tr h="475488">
-                <a:tc>
-                  <a:txBody>
-                    <a:bodyPr/>
-                    <a:lstStyle/>
-                    <a:p>
-                      <a:pPr>
-                        <a:lnSpc>
-                          <a:spcPct val="100000"/>
-                        </a:lnSpc>
-                        <a:defRPr sz="1350" b="1">
-                          <a:solidFill>
-                            <a:srgbClr val="000000"/>
-                          </a:solidFill>
-                          <a:latin typeface="Calibri"/>
-                        </a:defRPr>
-                      </a:pPr>
-                      <a:r>
-                        <a:t>Drawback in the paper</a:t>
-                      </a:r>
-                    </a:p>
-                  </a:txBody>
-                  <a:tcPr marL="54864" marR="54864" marT="27432" marB="27432" anchor="ctr">
-                    <a:solidFill>
-                      <a:srgbClr val="F2F2F2"/>
-                    </a:solidFill>
-                  </a:tcPr>
-                </a:tc>
-                <a:tc>
-                  <a:txBody>
-                    <a:bodyPr/>
-                    <a:lstStyle/>
-                    <a:p>
-                      <a:pPr>
-                        <a:lnSpc>
-                          <a:spcPct val="100000"/>
-                        </a:lnSpc>
-                        <a:defRPr sz="1350" b="1">
-                          <a:solidFill>
-                            <a:srgbClr val="000000"/>
-                          </a:solidFill>
-                          <a:latin typeface="Calibri"/>
-                        </a:defRPr>
-                      </a:pPr>
-                      <a:r>
-                        <a:t>Fix in this implementation</a:t>
-                      </a:r>
-                    </a:p>
-                  </a:txBody>
-                  <a:tcPr marL="54864" marR="54864" marT="27432" marB="27432" anchor="ctr">
-                    <a:solidFill>
-                      <a:srgbClr val="F2F2F2"/>
-                    </a:solidFill>
-                  </a:tcPr>
-                </a:tc>
-              </a:tr>
-              <a:tr h="731520">
-                <a:tc>
-                  <a:txBody>
-                    <a:bodyPr/>
-                    <a:lstStyle/>
-                    <a:p>
-                      <a:pPr>
-                        <a:lnSpc>
-                          <a:spcPct val="100000"/>
-                        </a:lnSpc>
-                        <a:defRPr sz="1250" b="0">
-                          <a:solidFill>
-                            <a:srgbClr val="000000"/>
-                          </a:solidFill>
-                          <a:latin typeface="Calibri"/>
-                        </a:defRPr>
-                      </a:pPr>
-                      <a:r>
-                        <a:t>Static, limited knowledge base (small coverage)</a:t>
-                      </a:r>
-                    </a:p>
-                  </a:txBody>
-                  <a:tcPr marL="54864" marR="54864" marT="27432" marB="27432" anchor="ctr"/>
-                </a:tc>
-                <a:tc>
-                  <a:txBody>
-                    <a:bodyPr/>
-                    <a:lstStyle/>
-                    <a:p>
-                      <a:pPr>
-                        <a:lnSpc>
-                          <a:spcPct val="100000"/>
-                        </a:lnSpc>
-                        <a:defRPr sz="1250" b="0">
-                          <a:solidFill>
-                            <a:srgbClr val="000000"/>
-                          </a:solidFill>
-                          <a:latin typeface="Calibri"/>
-                        </a:defRPr>
-                      </a:pPr>
-                      <a:r>
-                        <a:t>LLM judge answers any health claim; live Wikipedia evidence at query time</a:t>
-                      </a:r>
-                    </a:p>
-                  </a:txBody>
-                  <a:tcPr marL="54864" marR="54864" marT="27432" marB="27432" anchor="ctr"/>
-                </a:tc>
-              </a:tr>
-              <a:tr h="731520">
-                <a:tc>
-                  <a:txBody>
-                    <a:bodyPr/>
-                    <a:lstStyle/>
-                    <a:p>
-                      <a:pPr>
-                        <a:lnSpc>
-                          <a:spcPct val="100000"/>
-                        </a:lnSpc>
-                        <a:defRPr sz="1250" b="0">
-                          <a:solidFill>
-                            <a:srgbClr val="000000"/>
-                          </a:solidFill>
-                          <a:latin typeface="Calibri"/>
-                        </a:defRPr>
-                      </a:pPr>
-                      <a:r>
-                        <a:t>LLM hallucination / confident wrong answers</a:t>
-                      </a:r>
-                    </a:p>
-                  </a:txBody>
-                  <a:tcPr marL="54864" marR="54864" marT="27432" marB="27432" anchor="ctr"/>
-                </a:tc>
-                <a:tc>
-                  <a:txBody>
-                    <a:bodyPr/>
-                    <a:lstStyle/>
-                    <a:p>
-                      <a:pPr>
-                        <a:lnSpc>
-                          <a:spcPct val="100000"/>
-                        </a:lnSpc>
-                        <a:defRPr sz="1250" b="0">
-                          <a:solidFill>
-                            <a:srgbClr val="000000"/>
-                          </a:solidFill>
-                          <a:latin typeface="Calibri"/>
-                        </a:defRPr>
-                      </a:pPr>
-                      <a:r>
-                        <a:t>Evidence-grounded judging plus explicit Undetermined abstention</a:t>
-                      </a:r>
-                    </a:p>
-                  </a:txBody>
-                  <a:tcPr marL="54864" marR="54864" marT="27432" marB="27432" anchor="ctr"/>
-                </a:tc>
-              </a:tr>
-              <a:tr h="731520">
-                <a:tc>
-                  <a:txBody>
-                    <a:bodyPr/>
-                    <a:lstStyle/>
-                    <a:p>
-                      <a:pPr>
-                        <a:lnSpc>
-                          <a:spcPct val="100000"/>
-                        </a:lnSpc>
-                        <a:defRPr sz="1250" b="0">
-                          <a:solidFill>
-                            <a:srgbClr val="000000"/>
-                          </a:solidFill>
-                          <a:latin typeface="Calibri"/>
-                        </a:defRPr>
-                      </a:pPr>
-                      <a:r>
-                        <a:t>Rule-based triple extraction errors</a:t>
-                      </a:r>
-                    </a:p>
-                  </a:txBody>
-                  <a:tcPr marL="54864" marR="54864" marT="27432" marB="27432" anchor="ctr"/>
-                </a:tc>
-                <a:tc>
-                  <a:txBody>
-                    <a:bodyPr/>
-                    <a:lstStyle/>
-                    <a:p>
-                      <a:pPr>
-                        <a:lnSpc>
-                          <a:spcPct val="100000"/>
-                        </a:lnSpc>
-                        <a:defRPr sz="1250" b="0">
-                          <a:solidFill>
-                            <a:srgbClr val="000000"/>
-                          </a:solidFill>
-                          <a:latin typeface="Calibri"/>
-                        </a:defRPr>
-                      </a:pPr>
-                      <a:r>
-                        <a:t>LLM judging replaces reliance on the rule triples for the verdict</a:t>
-                      </a:r>
-                    </a:p>
-                  </a:txBody>
-                  <a:tcPr marL="54864" marR="54864" marT="27432" marB="27432" anchor="ctr"/>
-                </a:tc>
-              </a:tr>
-              <a:tr h="731520">
-                <a:tc>
-                  <a:txBody>
-                    <a:bodyPr/>
-                    <a:lstStyle/>
-                    <a:p>
-                      <a:pPr>
-                        <a:lnSpc>
-                          <a:spcPct val="100000"/>
-                        </a:lnSpc>
-                        <a:defRPr sz="1250" b="0">
-                          <a:solidFill>
-                            <a:srgbClr val="000000"/>
-                          </a:solidFill>
-                          <a:latin typeface="Calibri"/>
-                        </a:defRPr>
-                      </a:pPr>
-                      <a:r>
-                        <a:t>Six-level rating collapsed to binary</a:t>
-                      </a:r>
-                    </a:p>
-                  </a:txBody>
-                  <a:tcPr marL="54864" marR="54864" marT="27432" marB="27432" anchor="ctr"/>
-                </a:tc>
-                <a:tc>
-                  <a:txBody>
-                    <a:bodyPr/>
-                    <a:lstStyle/>
-                    <a:p>
-                      <a:pPr>
-                        <a:lnSpc>
-                          <a:spcPct val="100000"/>
-                        </a:lnSpc>
-                        <a:defRPr sz="1250" b="0">
-                          <a:solidFill>
-                            <a:srgbClr val="000000"/>
-                          </a:solidFill>
-                          <a:latin typeface="Calibri"/>
-                        </a:defRPr>
-                      </a:pPr>
-                      <a:r>
-                        <a:t>Kept binary for parity; the judge returns a short reason for review</a:t>
-                      </a:r>
-                    </a:p>
-                  </a:txBody>
-                  <a:tcPr marL="54864" marR="54864" marT="27432" marB="27432" anchor="ctr"/>
-                </a:tc>
-              </a:tr>
-              <a:tr h="731520">
-                <a:tc>
-                  <a:txBody>
-                    <a:bodyPr/>
-                    <a:lstStyle/>
-                    <a:p>
-                      <a:pPr>
-                        <a:lnSpc>
-                          <a:spcPct val="100000"/>
-                        </a:lnSpc>
-                        <a:defRPr sz="1250" b="0">
-                          <a:solidFill>
-                            <a:srgbClr val="000000"/>
-                          </a:solidFill>
-                          <a:latin typeface="Calibri"/>
-                        </a:defRPr>
-                      </a:pPr>
-                      <a:r>
-                        <a:t>Hard to reproduce / no test harness</a:t>
-                      </a:r>
-                    </a:p>
-                  </a:txBody>
-                  <a:tcPr marL="54864" marR="54864" marT="27432" marB="27432" anchor="ctr"/>
-                </a:tc>
-                <a:tc>
-                  <a:txBody>
-                    <a:bodyPr/>
-                    <a:lstStyle/>
-                    <a:p>
-                      <a:pPr>
-                        <a:lnSpc>
-                          <a:spcPct val="100000"/>
-                        </a:lnSpc>
-                        <a:defRPr sz="1250" b="0">
-                          <a:solidFill>
-                            <a:srgbClr val="000000"/>
-                          </a:solidFill>
-                          <a:latin typeface="Calibri"/>
-                        </a:defRPr>
-                      </a:pPr>
-                      <a:r>
-                        <a:t>Nine tests, seeded evaluation sets, one-command reproduce script</a:t>
-                      </a:r>
-                    </a:p>
-                  </a:txBody>
-                  <a:tcPr marL="54864" marR="54864" marT="27432" marB="27432" anchor="ctr"/>
-                </a:tc>
-              </a:tr>
-            </a:tbl>
-          </a:graphicData>
-        </a:graphic>
-      </p:graphicFrame>
-    </p:spTree>
-  </p:cSld>
-  <p:clrMapOvr>
-    <a:masterClrMapping/>
-  </p:clrMapOvr>
-</p:sld>
-</file>
-
-<file path=ppt/slides/slide6.xml><?xml version="1.0" encoding="utf-8"?>
-<p:sld xmlns:a="http://schemas.openxmlformats.org/drawingml/2006/main" xmlns:p="http://schemas.openxmlformats.org/presentationml/2006/main" xmlns:r="http://schemas.openxmlformats.org/officeDocument/2006/relationships">
-  <p:cSld>
-    <p:spTree>
-      <p:nvGrpSpPr>
-        <p:cNvPr id="1" name=""/>
-        <p:cNvGrpSpPr/>
-        <p:nvPr/>
-      </p:nvGrpSpPr>
-      <p:grpSpPr/>
-      <p:sp>
-        <p:nvSpPr>
-          <p:cNvPr id="2" name="TextBox 1"/>
-          <p:cNvSpPr txBox="1"/>
-          <p:nvPr/>
-        </p:nvSpPr>
-        <p:spPr>
-          <a:xfrm>
-            <a:off x="640080" y="347472"/>
-            <a:ext cx="10927080" cy="914400"/>
-          </a:xfrm>
-          <a:prstGeom prst="rect">
-            <a:avLst/>
-          </a:prstGeom>
-          <a:noFill/>
-        </p:spPr>
-        <p:txBody>
-          <a:bodyPr wrap="square">
-            <a:spAutoFit/>
-          </a:bodyPr>
-          <a:lstStyle/>
-          <a:p>
-            <a:pPr>
-              <a:defRPr sz="3200" b="1">
-                <a:solidFill>
-                  <a:srgbClr val="1F1F1F"/>
-                </a:solidFill>
-                <a:latin typeface="Calibri"/>
-              </a:defRPr>
-            </a:pPr>
-            <a:r>
-              <a:t>Results (Base Paper Benchmark)</a:t>
-            </a:r>
-          </a:p>
-        </p:txBody>
-      </p:sp>
-      <p:sp>
-        <p:nvSpPr>
-          <p:cNvPr id="3" name="Rectangle 2"/>
-          <p:cNvSpPr/>
-          <p:nvPr/>
-        </p:nvSpPr>
-        <p:spPr>
-          <a:xfrm>
-            <a:off x="640080" y="1298448"/>
-            <a:ext cx="10927080" cy="17780"/>
-          </a:xfrm>
-          <a:prstGeom prst="rect">
-            <a:avLst/>
-          </a:prstGeom>
-          <a:solidFill>
-            <a:srgbClr val="BFBFBF"/>
-          </a:solidFill>
-          <a:ln>
-            <a:noFill/>
-          </a:ln>
-          <a:effectLst/>
-        </p:spPr>
-        <p:style>
-          <a:lnRef idx="1">
-            <a:schemeClr val="accent1"/>
-          </a:lnRef>
-          <a:fillRef idx="3">
-            <a:schemeClr val="accent1"/>
-          </a:fillRef>
-          <a:effectRef idx="2">
-            <a:schemeClr val="accent1"/>
-          </a:effectRef>
-          <a:fontRef idx="minor">
-            <a:schemeClr val="lt1"/>
-          </a:fontRef>
-        </p:style>
-        <p:txBody>
-          <a:bodyPr rtlCol="0" anchor="ctr"/>
-          <a:lstStyle/>
-          <a:p>
-            <a:pPr algn="ctr"/>
-          </a:p>
-        </p:txBody>
-      </p:sp>
-      <p:graphicFrame>
-        <p:nvGraphicFramePr>
-          <p:cNvPr id="4" name="Table 3"/>
-          <p:cNvGraphicFramePr>
-            <a:graphicFrameLocks noGrp="1"/>
-          </p:cNvGraphicFramePr>
-          <p:nvPr/>
-        </p:nvGraphicFramePr>
-        <p:xfrm>
-          <a:off x="502920" y="1417320"/>
-          <a:ext cx="11521440" cy="3739896"/>
+          <a:off x="502920" y="1325880"/>
+          <a:ext cx="11521440" cy="3355848"/>
         </p:xfrm>
         <a:graphic>
           <a:graphicData uri="http://schemas.openxmlformats.org/drawingml/2006/table">
@@ -5370,7 +4660,7 @@
                   </a:tcPr>
                 </a:tc>
               </a:tr>
-              <a:tr h="475488">
+              <a:tr h="420624">
                 <a:tc>
                   <a:txBody>
                     <a:bodyPr/>
@@ -5487,7 +4777,7 @@
                   <a:tcPr marL="54864" marR="54864" marT="27432" marB="27432" anchor="ctr"/>
                 </a:tc>
               </a:tr>
-              <a:tr h="475488">
+              <a:tr h="420624">
                 <a:tc>
                   <a:txBody>
                     <a:bodyPr/>
@@ -5604,7 +4894,7 @@
                   <a:tcPr marL="54864" marR="54864" marT="27432" marB="27432" anchor="ctr"/>
                 </a:tc>
               </a:tr>
-              <a:tr h="475488">
+              <a:tr h="420624">
                 <a:tc>
                   <a:txBody>
                     <a:bodyPr/>
@@ -5721,7 +5011,7 @@
                   <a:tcPr marL="54864" marR="54864" marT="27432" marB="27432" anchor="ctr"/>
                 </a:tc>
               </a:tr>
-              <a:tr h="475488">
+              <a:tr h="420624">
                 <a:tc>
                   <a:txBody>
                     <a:bodyPr/>
@@ -5838,7 +5128,7 @@
                   <a:tcPr marL="54864" marR="54864" marT="27432" marB="27432" anchor="ctr"/>
                 </a:tc>
               </a:tr>
-              <a:tr h="475488">
+              <a:tr h="420624">
                 <a:tc>
                   <a:txBody>
                     <a:bodyPr/>
@@ -5955,7 +5245,7 @@
                   <a:tcPr marL="54864" marR="54864" marT="27432" marB="27432" anchor="ctr"/>
                 </a:tc>
               </a:tr>
-              <a:tr h="475488">
+              <a:tr h="420624">
                 <a:tc>
                   <a:txBody>
                     <a:bodyPr/>
@@ -6072,7 +5362,7 @@
                   <a:tcPr marL="54864" marR="54864" marT="27432" marB="27432" anchor="ctr"/>
                 </a:tc>
               </a:tr>
-              <a:tr h="475488">
+              <a:tr h="420624">
                 <a:tc>
                   <a:txBody>
                     <a:bodyPr/>
@@ -6201,8 +5491,8 @@
         </p:nvSpPr>
         <p:spPr>
           <a:xfrm>
-            <a:off x="777240" y="5806440"/>
-            <a:ext cx="10698480" cy="731520"/>
+            <a:off x="777240" y="4892040"/>
+            <a:ext cx="10698480" cy="1645920"/>
           </a:xfrm>
           <a:prstGeom prst="rect">
             <a:avLst/>
@@ -6239,7 +5529,81 @@
                 </a:solidFill>
                 <a:latin typeface="Calibri"/>
               </a:rPr>
-              <a:t>Results as reported in the base paper on 600 PolitiFact claims (300 true / 300 false). TrumorGPT leads every metric, about 5.2 points above GPT-4 on accuracy.</a:t>
+              <a:t>Results as reported in the base paper (600 PolitiFact claims, 300 true / 300 false); TrumorGPT leads every metric, about 5.2 points above GPT-4 on accuracy.</a:t>
+            </a:r>
+          </a:p>
+          <a:p>
+            <a:pPr>
+              <a:lnSpc>
+                <a:spcPct val="108000"/>
+              </a:lnSpc>
+              <a:spcAft>
+                <a:spcPts val="1000"/>
+              </a:spcAft>
+            </a:pPr>
+            <a:r>
+              <a:rPr sz="1300">
+                <a:solidFill>
+                  <a:srgbClr val="000000"/>
+                </a:solidFill>
+                <a:latin typeface="Calibri"/>
+              </a:rPr>
+              <a:t>•  </a:t>
+            </a:r>
+            <a:r>
+              <a:rPr sz="1300" b="1">
+                <a:solidFill>
+                  <a:srgbClr val="000000"/>
+                </a:solidFill>
+                <a:latin typeface="Calibri"/>
+              </a:rPr>
+              <a:t>Published health fact-checking benchmarks:</a:t>
+            </a:r>
+            <a:r>
+              <a:rPr sz="1300" b="0">
+                <a:solidFill>
+                  <a:srgbClr val="000000"/>
+                </a:solidFill>
+                <a:latin typeface="Calibri"/>
+              </a:rPr>
+              <a:t> SciFact about 70% (gold abstracts); PUBHEALTH SciBERT 69.7% acc; HealthVer claim-only 50.0%.</a:t>
+            </a:r>
+          </a:p>
+          <a:p>
+            <a:pPr>
+              <a:lnSpc>
+                <a:spcPct val="108000"/>
+              </a:lnSpc>
+              <a:spcAft>
+                <a:spcPts val="1000"/>
+              </a:spcAft>
+            </a:pPr>
+            <a:r>
+              <a:rPr sz="1300">
+                <a:solidFill>
+                  <a:srgbClr val="000000"/>
+                </a:solidFill>
+                <a:latin typeface="Calibri"/>
+              </a:rPr>
+              <a:t>•  </a:t>
+            </a:r>
+            <a:r>
+              <a:rPr sz="1300" b="1">
+                <a:solidFill>
+                  <a:srgbClr val="000000"/>
+                </a:solidFill>
+                <a:latin typeface="Calibri"/>
+              </a:rPr>
+              <a:t>Our implementation:</a:t>
+            </a:r>
+            <a:r>
+              <a:rPr sz="1300" b="0">
+                <a:solidFill>
+                  <a:srgbClr val="000000"/>
+                </a:solidFill>
+                <a:latin typeface="Calibri"/>
+              </a:rPr>
+              <a:t> 91.7% on the isolated verification component.</a:t>
             </a:r>
           </a:p>
         </p:txBody>
@@ -6252,7 +5616,7 @@
 </p:sld>
 </file>
 
-<file path=ppt/slides/slide7.xml><?xml version="1.0" encoding="utf-8"?>
+<file path=ppt/slides/slide6.xml><?xml version="1.0" encoding="utf-8"?>
 <p:sld xmlns:a="http://schemas.openxmlformats.org/drawingml/2006/main" xmlns:p="http://schemas.openxmlformats.org/presentationml/2006/main" xmlns:r="http://schemas.openxmlformats.org/officeDocument/2006/relationships">
   <p:cSld>
     <p:spTree>
@@ -6293,7 +5657,7 @@
               </a:defRPr>
             </a:pPr>
             <a:r>
-              <a:t>Comparison with State-of-the-Art</a:t>
+              <a:t>Implementation (Live)</a:t>
             </a:r>
           </a:p>
         </p:txBody>
@@ -6342,213 +5706,54 @@
           </a:p>
         </p:txBody>
       </p:sp>
-      <p:sp>
-        <p:nvSpPr>
-          <p:cNvPr id="4" name="TextBox 3"/>
-          <p:cNvSpPr txBox="1"/>
+      <p:pic>
+        <p:nvPicPr>
+          <p:cNvPr id="4" name="Picture 3" descr="result_app.png"/>
+          <p:cNvPicPr>
+            <a:picLocks noChangeAspect="1"/>
+          </p:cNvPicPr>
           <p:nvPr/>
-        </p:nvSpPr>
+        </p:nvPicPr>
+        <p:blipFill>
+          <a:blip r:embed="rId2"/>
+          <a:stretch>
+            <a:fillRect/>
+          </a:stretch>
+        </p:blipFill>
         <p:spPr>
           <a:xfrm>
-            <a:off x="777240" y="1600200"/>
-            <a:ext cx="10698480" cy="4937760"/>
+            <a:off x="457200" y="1554480"/>
+            <a:ext cx="6858000" cy="3461153"/>
           </a:xfrm>
           <a:prstGeom prst="rect">
             <a:avLst/>
           </a:prstGeom>
-          <a:noFill/>
         </p:spPr>
-        <p:txBody>
-          <a:bodyPr wrap="square">
-            <a:spAutoFit/>
-          </a:bodyPr>
-          <a:lstStyle/>
-          <a:p>
-            <a:pPr>
-              <a:lnSpc>
-                <a:spcPct val="108000"/>
-              </a:lnSpc>
-              <a:spcAft>
-                <a:spcPts val="1000"/>
-              </a:spcAft>
-            </a:pPr>
-            <a:r>
-              <a:rPr sz="1700">
-                <a:solidFill>
-                  <a:srgbClr val="000000"/>
-                </a:solidFill>
-                <a:latin typeface="Calibri"/>
-              </a:rPr>
-              <a:t>•  </a:t>
-            </a:r>
-            <a:r>
-              <a:rPr sz="1700" b="1">
-                <a:solidFill>
-                  <a:srgbClr val="000000"/>
-                </a:solidFill>
-                <a:latin typeface="Calibri"/>
-              </a:rPr>
-              <a:t>Base paper (same task, 600 claims):</a:t>
-            </a:r>
-            <a:r>
-              <a:rPr sz="1700" b="0">
-                <a:solidFill>
-                  <a:srgbClr val="000000"/>
-                </a:solidFill>
-                <a:latin typeface="Calibri"/>
-              </a:rPr>
-              <a:t> TrumorGPT 88.5% acc, GPT-4 83.3%, LLaMA 3.2 81.8%, Gemini 1.5 81.7% [paper-reported].</a:t>
-            </a:r>
-          </a:p>
-          <a:p>
-            <a:pPr>
-              <a:lnSpc>
-                <a:spcPct val="108000"/>
-              </a:lnSpc>
-              <a:spcAft>
-                <a:spcPts val="1000"/>
-              </a:spcAft>
-            </a:pPr>
-            <a:r>
-              <a:rPr sz="1700">
-                <a:solidFill>
-                  <a:srgbClr val="000000"/>
-                </a:solidFill>
-                <a:latin typeface="Calibri"/>
-              </a:rPr>
-              <a:t>•  </a:t>
-            </a:r>
-            <a:r>
-              <a:rPr sz="1700" b="1">
-                <a:solidFill>
-                  <a:srgbClr val="000000"/>
-                </a:solidFill>
-                <a:latin typeface="Calibri"/>
-              </a:rPr>
-              <a:t>Published health fact-checking benchmarks:</a:t>
-            </a:r>
-            <a:r>
-              <a:rPr sz="1700" b="0">
-                <a:solidFill>
-                  <a:srgbClr val="000000"/>
-                </a:solidFill>
-                <a:latin typeface="Calibri"/>
-              </a:rPr>
-              <a:t> SciFact about 70% (gold abstracts); PUBHEALTH SciBERT 69.7% acc; HealthVer claim-only 50.0%.</a:t>
-            </a:r>
-          </a:p>
-          <a:p>
-            <a:pPr>
-              <a:lnSpc>
-                <a:spcPct val="108000"/>
-              </a:lnSpc>
-              <a:spcAft>
-                <a:spcPts val="1000"/>
-              </a:spcAft>
-            </a:pPr>
-            <a:r>
-              <a:rPr sz="1700">
-                <a:solidFill>
-                  <a:srgbClr val="000000"/>
-                </a:solidFill>
-                <a:latin typeface="Calibri"/>
-              </a:rPr>
-              <a:t>•  </a:t>
-            </a:r>
-            <a:r>
-              <a:rPr sz="1700" b="1">
-                <a:solidFill>
-                  <a:srgbClr val="000000"/>
-                </a:solidFill>
-                <a:latin typeface="Calibri"/>
-              </a:rPr>
-              <a:t>LIAR baseline:</a:t>
-            </a:r>
-            <a:r>
-              <a:rPr sz="1700" b="0">
-                <a:solidFill>
-                  <a:srgbClr val="000000"/>
-                </a:solidFill>
-                <a:latin typeface="Calibri"/>
-              </a:rPr>
-              <a:t> majority 20.8% on test; a plain classifier is the weakest reference for this task.</a:t>
-            </a:r>
-          </a:p>
-          <a:p>
-            <a:pPr>
-              <a:lnSpc>
-                <a:spcPct val="108000"/>
-              </a:lnSpc>
-              <a:spcAft>
-                <a:spcPts val="1000"/>
-              </a:spcAft>
-            </a:pPr>
-            <a:r>
-              <a:rPr sz="1700">
-                <a:solidFill>
-                  <a:srgbClr val="000000"/>
-                </a:solidFill>
-                <a:latin typeface="Calibri"/>
-              </a:rPr>
-              <a:t>•  </a:t>
-            </a:r>
-            <a:r>
-              <a:rPr sz="1700" b="1">
-                <a:solidFill>
-                  <a:srgbClr val="000000"/>
-                </a:solidFill>
-                <a:latin typeface="Calibri"/>
-              </a:rPr>
-              <a:t>Our system:</a:t>
-            </a:r>
-            <a:r>
-              <a:rPr sz="1700" b="0">
-                <a:solidFill>
-                  <a:srgbClr val="000000"/>
-                </a:solidFill>
-                <a:latin typeface="Calibri"/>
-              </a:rPr>
-              <a:t> 91.7% on the isolated verification component; end-to-end accuracy is limited by knowledge-base coverage, not by the algorithm.</a:t>
-            </a:r>
-          </a:p>
-        </p:txBody>
-      </p:sp>
-      <p:sp>
-        <p:nvSpPr>
-          <p:cNvPr id="5" name="TextBox 4"/>
-          <p:cNvSpPr txBox="1"/>
+      </p:pic>
+      <p:pic>
+        <p:nvPicPr>
+          <p:cNvPr id="5" name="Picture 4" descr="landing.png"/>
+          <p:cNvPicPr>
+            <a:picLocks noChangeAspect="1"/>
+          </p:cNvPicPr>
           <p:nvPr/>
-        </p:nvSpPr>
+        </p:nvPicPr>
+        <p:blipFill>
+          <a:blip r:embed="rId3"/>
+          <a:stretch>
+            <a:fillRect/>
+          </a:stretch>
+        </p:blipFill>
         <p:spPr>
           <a:xfrm>
-            <a:off x="731520" y="6035040"/>
-            <a:ext cx="10789920" cy="640080"/>
+            <a:off x="7498079" y="1554480"/>
+            <a:ext cx="4206240" cy="2126359"/>
           </a:xfrm>
           <a:prstGeom prst="rect">
             <a:avLst/>
           </a:prstGeom>
-          <a:noFill/>
         </p:spPr>
-        <p:txBody>
-          <a:bodyPr wrap="none">
-            <a:spAutoFit/>
-          </a:bodyPr>
-          <a:lstStyle/>
-          <a:p>
-            <a:pPr>
-              <a:defRPr sz="1200" i="1">
-                <a:solidFill>
-                  <a:srgbClr val="595959"/>
-                </a:solidFill>
-                <a:latin typeface="Calibri"/>
-              </a:defRPr>
-            </a:pPr>
-            <a:r>
-              <a:t>Published figures are cited in docs/sources.md; they are not our measurements.</a:t>
-            </a:r>
-          </a:p>
-        </p:txBody>
-      </p:sp>
+      </p:pic>
     </p:spTree>
   </p:cSld>
   <p:clrMapOvr>
@@ -6557,7 +5762,7 @@
 </p:sld>
 </file>
 
-<file path=ppt/slides/slide8.xml><?xml version="1.0" encoding="utf-8"?>
+<file path=ppt/slides/slide7.xml><?xml version="1.0" encoding="utf-8"?>
 <p:sld xmlns:a="http://schemas.openxmlformats.org/drawingml/2006/main" xmlns:p="http://schemas.openxmlformats.org/presentationml/2006/main" xmlns:r="http://schemas.openxmlformats.org/officeDocument/2006/relationships">
   <p:cSld>
     <p:spTree>
@@ -6598,7 +5803,7 @@
               </a:defRPr>
             </a:pPr>
             <a:r>
-              <a:t>Hallucination Reduction</a:t>
+              <a:t>Demo and Future Work</a:t>
             </a:r>
           </a:p>
         </p:txBody>
@@ -6647,530 +5852,16 @@
           </a:p>
         </p:txBody>
       </p:sp>
-      <p:graphicFrame>
-        <p:nvGraphicFramePr>
-          <p:cNvPr id="4" name="Table 3"/>
-          <p:cNvGraphicFramePr>
-            <a:graphicFrameLocks noGrp="1"/>
-          </p:cNvGraphicFramePr>
-          <p:nvPr/>
-        </p:nvGraphicFramePr>
-        <p:xfrm>
-          <a:off x="502920" y="1417320"/>
-          <a:ext cx="11612880" cy="2976371"/>
-        </p:xfrm>
-        <a:graphic>
-          <a:graphicData uri="http://schemas.openxmlformats.org/drawingml/2006/table">
-            <a:tbl>
-              <a:tblPr firstRow="1" bandRow="1">
-                <a:tableStyleId>{5940675A-B579-460E-94D1-54222C63F5DA}</a:tableStyleId>
-              </a:tblPr>
-              <a:tblGrid>
-                <a:gridCol w="4206240"/>
-                <a:gridCol w="3840480"/>
-                <a:gridCol w="1554480"/>
-                <a:gridCol w="2011680"/>
-              </a:tblGrid>
-              <a:tr h="416051">
-                <a:tc>
-                  <a:txBody>
-                    <a:bodyPr/>
-                    <a:lstStyle/>
-                    <a:p>
-                      <a:pPr>
-                        <a:lnSpc>
-                          <a:spcPct val="100000"/>
-                        </a:lnSpc>
-                        <a:defRPr sz="1250" b="1">
-                          <a:solidFill>
-                            <a:srgbClr val="000000"/>
-                          </a:solidFill>
-                          <a:latin typeface="Calibri"/>
-                        </a:defRPr>
-                      </a:pPr>
-                      <a:r>
-                        <a:t>Setting</a:t>
-                      </a:r>
-                    </a:p>
-                  </a:txBody>
-                  <a:tcPr marL="54864" marR="54864" marT="27432" marB="27432" anchor="ctr">
-                    <a:solidFill>
-                      <a:srgbClr val="F2F2F2"/>
-                    </a:solidFill>
-                  </a:tcPr>
-                </a:tc>
-                <a:tc>
-                  <a:txBody>
-                    <a:bodyPr/>
-                    <a:lstStyle/>
-                    <a:p>
-                      <a:pPr>
-                        <a:lnSpc>
-                          <a:spcPct val="100000"/>
-                        </a:lnSpc>
-                        <a:defRPr sz="1250" b="1">
-                          <a:solidFill>
-                            <a:srgbClr val="000000"/>
-                          </a:solidFill>
-                          <a:latin typeface="Calibri"/>
-                        </a:defRPr>
-                      </a:pPr>
-                      <a:r>
-                        <a:t>Hallucination rate (confident-wrong)</a:t>
-                      </a:r>
-                    </a:p>
-                  </a:txBody>
-                  <a:tcPr marL="54864" marR="54864" marT="27432" marB="27432" anchor="ctr">
-                    <a:solidFill>
-                      <a:srgbClr val="F2F2F2"/>
-                    </a:solidFill>
-                  </a:tcPr>
-                </a:tc>
-                <a:tc>
-                  <a:txBody>
-                    <a:bodyPr/>
-                    <a:lstStyle/>
-                    <a:p>
-                      <a:pPr>
-                        <a:lnSpc>
-                          <a:spcPct val="100000"/>
-                        </a:lnSpc>
-                        <a:defRPr sz="1250" b="1">
-                          <a:solidFill>
-                            <a:srgbClr val="000000"/>
-                          </a:solidFill>
-                          <a:latin typeface="Calibri"/>
-                        </a:defRPr>
-                      </a:pPr>
-                      <a:r>
-                        <a:t>Coverage</a:t>
-                      </a:r>
-                    </a:p>
-                  </a:txBody>
-                  <a:tcPr marL="54864" marR="54864" marT="27432" marB="27432" anchor="ctr">
-                    <a:solidFill>
-                      <a:srgbClr val="F2F2F2"/>
-                    </a:solidFill>
-                  </a:tcPr>
-                </a:tc>
-                <a:tc>
-                  <a:txBody>
-                    <a:bodyPr/>
-                    <a:lstStyle/>
-                    <a:p>
-                      <a:pPr>
-                        <a:lnSpc>
-                          <a:spcPct val="100000"/>
-                        </a:lnSpc>
-                        <a:defRPr sz="1250" b="1">
-                          <a:solidFill>
-                            <a:srgbClr val="000000"/>
-                          </a:solidFill>
-                          <a:latin typeface="Calibri"/>
-                        </a:defRPr>
-                      </a:pPr>
-                      <a:r>
-                        <a:t>Source</a:t>
-                      </a:r>
-                    </a:p>
-                  </a:txBody>
-                  <a:tcPr marL="54864" marR="54864" marT="27432" marB="27432" anchor="ctr">
-                    <a:solidFill>
-                      <a:srgbClr val="F2F2F2"/>
-                    </a:solidFill>
-                  </a:tcPr>
-                </a:tc>
-              </a:tr>
-              <a:tr h="640080">
-                <a:tc>
-                  <a:txBody>
-                    <a:bodyPr/>
-                    <a:lstStyle/>
-                    <a:p>
-                      <a:pPr>
-                        <a:lnSpc>
-                          <a:spcPct val="100000"/>
-                        </a:lnSpc>
-                        <a:defRPr sz="1200" b="0">
-                          <a:solidFill>
-                            <a:srgbClr val="000000"/>
-                          </a:solidFill>
-                          <a:latin typeface="Calibri"/>
-                        </a:defRPr>
-                      </a:pPr>
-                      <a:r>
-                        <a:t>Plain LLM, no retrieval</a:t>
-                      </a:r>
-                    </a:p>
-                  </a:txBody>
-                  <a:tcPr marL="54864" marR="54864" marT="27432" marB="27432" anchor="ctr"/>
-                </a:tc>
-                <a:tc>
-                  <a:txBody>
-                    <a:bodyPr/>
-                    <a:lstStyle/>
-                    <a:p>
-                      <a:pPr>
-                        <a:lnSpc>
-                          <a:spcPct val="100000"/>
-                        </a:lnSpc>
-                        <a:defRPr sz="1200" b="0">
-                          <a:solidFill>
-                            <a:srgbClr val="000000"/>
-                          </a:solidFill>
-                          <a:latin typeface="Calibri"/>
-                        </a:defRPr>
-                      </a:pPr>
-                      <a:r>
-                        <a:t>43.8%</a:t>
-                      </a:r>
-                    </a:p>
-                  </a:txBody>
-                  <a:tcPr marL="54864" marR="54864" marT="27432" marB="27432" anchor="ctr"/>
-                </a:tc>
-                <a:tc>
-                  <a:txBody>
-                    <a:bodyPr/>
-                    <a:lstStyle/>
-                    <a:p>
-                      <a:pPr>
-                        <a:lnSpc>
-                          <a:spcPct val="100000"/>
-                        </a:lnSpc>
-                        <a:defRPr sz="1200" b="0">
-                          <a:solidFill>
-                            <a:srgbClr val="000000"/>
-                          </a:solidFill>
-                          <a:latin typeface="Calibri"/>
-                        </a:defRPr>
-                      </a:pPr>
-                      <a:r>
-                        <a:t>53%</a:t>
-                      </a:r>
-                    </a:p>
-                  </a:txBody>
-                  <a:tcPr marL="54864" marR="54864" marT="27432" marB="27432" anchor="ctr"/>
-                </a:tc>
-                <a:tc>
-                  <a:txBody>
-                    <a:bodyPr/>
-                    <a:lstStyle/>
-                    <a:p>
-                      <a:pPr>
-                        <a:lnSpc>
-                          <a:spcPct val="100000"/>
-                        </a:lnSpc>
-                        <a:defRPr sz="1200" b="0">
-                          <a:solidFill>
-                            <a:srgbClr val="000000"/>
-                          </a:solidFill>
-                          <a:latin typeface="Calibri"/>
-                        </a:defRPr>
-                      </a:pPr>
-                      <a:r>
-                        <a:t>ours (n=30)</a:t>
-                      </a:r>
-                    </a:p>
-                  </a:txBody>
-                  <a:tcPr marL="54864" marR="54864" marT="27432" marB="27432" anchor="ctr"/>
-                </a:tc>
-              </a:tr>
-              <a:tr h="640080">
-                <a:tc>
-                  <a:txBody>
-                    <a:bodyPr/>
-                    <a:lstStyle/>
-                    <a:p>
-                      <a:pPr>
-                        <a:lnSpc>
-                          <a:spcPct val="100000"/>
-                        </a:lnSpc>
-                        <a:defRPr sz="1200" b="0">
-                          <a:solidFill>
-                            <a:srgbClr val="000000"/>
-                          </a:solidFill>
-                          <a:latin typeface="Calibri"/>
-                        </a:defRPr>
-                      </a:pPr>
-                      <a:r>
-                        <a:t>Our system (retrieval + abstain)</a:t>
-                      </a:r>
-                    </a:p>
-                  </a:txBody>
-                  <a:tcPr marL="54864" marR="54864" marT="27432" marB="27432" anchor="ctr"/>
-                </a:tc>
-                <a:tc>
-                  <a:txBody>
-                    <a:bodyPr/>
-                    <a:lstStyle/>
-                    <a:p>
-                      <a:pPr>
-                        <a:lnSpc>
-                          <a:spcPct val="100000"/>
-                        </a:lnSpc>
-                        <a:defRPr sz="1200" b="0">
-                          <a:solidFill>
-                            <a:srgbClr val="000000"/>
-                          </a:solidFill>
-                          <a:latin typeface="Calibri"/>
-                        </a:defRPr>
-                      </a:pPr>
-                      <a:r>
-                        <a:t>33.3%</a:t>
-                      </a:r>
-                    </a:p>
-                  </a:txBody>
-                  <a:tcPr marL="54864" marR="54864" marT="27432" marB="27432" anchor="ctr"/>
-                </a:tc>
-                <a:tc>
-                  <a:txBody>
-                    <a:bodyPr/>
-                    <a:lstStyle/>
-                    <a:p>
-                      <a:pPr>
-                        <a:lnSpc>
-                          <a:spcPct val="100000"/>
-                        </a:lnSpc>
-                        <a:defRPr sz="1200" b="0">
-                          <a:solidFill>
-                            <a:srgbClr val="000000"/>
-                          </a:solidFill>
-                          <a:latin typeface="Calibri"/>
-                        </a:defRPr>
-                      </a:pPr>
-                      <a:r>
-                        <a:t>30%</a:t>
-                      </a:r>
-                    </a:p>
-                  </a:txBody>
-                  <a:tcPr marL="54864" marR="54864" marT="27432" marB="27432" anchor="ctr"/>
-                </a:tc>
-                <a:tc>
-                  <a:txBody>
-                    <a:bodyPr/>
-                    <a:lstStyle/>
-                    <a:p>
-                      <a:pPr>
-                        <a:lnSpc>
-                          <a:spcPct val="100000"/>
-                        </a:lnSpc>
-                        <a:defRPr sz="1200" b="0">
-                          <a:solidFill>
-                            <a:srgbClr val="000000"/>
-                          </a:solidFill>
-                          <a:latin typeface="Calibri"/>
-                        </a:defRPr>
-                      </a:pPr>
-                      <a:r>
-                        <a:t>ours (n=30)</a:t>
-                      </a:r>
-                    </a:p>
-                  </a:txBody>
-                  <a:tcPr marL="54864" marR="54864" marT="27432" marB="27432" anchor="ctr"/>
-                </a:tc>
-              </a:tr>
-              <a:tr h="640080">
-                <a:tc>
-                  <a:txBody>
-                    <a:bodyPr/>
-                    <a:lstStyle/>
-                    <a:p>
-                      <a:pPr>
-                        <a:lnSpc>
-                          <a:spcPct val="100000"/>
-                        </a:lnSpc>
-                        <a:defRPr sz="1200" b="0">
-                          <a:solidFill>
-                            <a:srgbClr val="000000"/>
-                          </a:solidFill>
-                          <a:latin typeface="Calibri"/>
-                        </a:defRPr>
-                      </a:pPr>
-                      <a:r>
-                        <a:t>AA-Omniscience, published range</a:t>
-                      </a:r>
-                    </a:p>
-                  </a:txBody>
-                  <a:tcPr marL="54864" marR="54864" marT="27432" marB="27432" anchor="ctr"/>
-                </a:tc>
-                <a:tc>
-                  <a:txBody>
-                    <a:bodyPr/>
-                    <a:lstStyle/>
-                    <a:p>
-                      <a:pPr>
-                        <a:lnSpc>
-                          <a:spcPct val="100000"/>
-                        </a:lnSpc>
-                        <a:defRPr sz="1200" b="0">
-                          <a:solidFill>
-                            <a:srgbClr val="000000"/>
-                          </a:solidFill>
-                          <a:latin typeface="Calibri"/>
-                        </a:defRPr>
-                      </a:pPr>
-                      <a:r>
-                        <a:t>26% to 81% across models</a:t>
-                      </a:r>
-                    </a:p>
-                  </a:txBody>
-                  <a:tcPr marL="54864" marR="54864" marT="27432" marB="27432" anchor="ctr"/>
-                </a:tc>
-                <a:tc>
-                  <a:txBody>
-                    <a:bodyPr/>
-                    <a:lstStyle/>
-                    <a:p>
-                      <a:pPr>
-                        <a:lnSpc>
-                          <a:spcPct val="100000"/>
-                        </a:lnSpc>
-                        <a:defRPr sz="1200" b="0">
-                          <a:solidFill>
-                            <a:srgbClr val="000000"/>
-                          </a:solidFill>
-                          <a:latin typeface="Calibri"/>
-                        </a:defRPr>
-                      </a:pPr>
-                      <a:r>
-                        <a:t>n/a</a:t>
-                      </a:r>
-                    </a:p>
-                  </a:txBody>
-                  <a:tcPr marL="54864" marR="54864" marT="27432" marB="27432" anchor="ctr"/>
-                </a:tc>
-                <a:tc>
-                  <a:txBody>
-                    <a:bodyPr/>
-                    <a:lstStyle/>
-                    <a:p>
-                      <a:pPr>
-                        <a:lnSpc>
-                          <a:spcPct val="100000"/>
-                        </a:lnSpc>
-                        <a:defRPr sz="1200" b="0">
-                          <a:solidFill>
-                            <a:srgbClr val="000000"/>
-                          </a:solidFill>
-                          <a:latin typeface="Calibri"/>
-                        </a:defRPr>
-                      </a:pPr>
-                      <a:r>
-                        <a:t>Artificial Analysis</a:t>
-                      </a:r>
-                    </a:p>
-                  </a:txBody>
-                  <a:tcPr marL="54864" marR="54864" marT="27432" marB="27432" anchor="ctr"/>
-                </a:tc>
-              </a:tr>
-              <a:tr h="640080">
-                <a:tc>
-                  <a:txBody>
-                    <a:bodyPr/>
-                    <a:lstStyle/>
-                    <a:p>
-                      <a:pPr>
-                        <a:lnSpc>
-                          <a:spcPct val="100000"/>
-                        </a:lnSpc>
-                        <a:defRPr sz="1200" b="0">
-                          <a:solidFill>
-                            <a:srgbClr val="000000"/>
-                          </a:solidFill>
-                          <a:latin typeface="Calibri"/>
-                        </a:defRPr>
-                      </a:pPr>
-                      <a:r>
-                        <a:t>RAG vs conventional (cancer Q&amp;A)</a:t>
-                      </a:r>
-                    </a:p>
-                  </a:txBody>
-                  <a:tcPr marL="54864" marR="54864" marT="27432" marB="27432" anchor="ctr"/>
-                </a:tc>
-                <a:tc>
-                  <a:txBody>
-                    <a:bodyPr/>
-                    <a:lstStyle/>
-                    <a:p>
-                      <a:pPr>
-                        <a:lnSpc>
-                          <a:spcPct val="100000"/>
-                        </a:lnSpc>
-                        <a:defRPr sz="1200" b="0">
-                          <a:solidFill>
-                            <a:srgbClr val="000000"/>
-                          </a:solidFill>
-                          <a:latin typeface="Calibri"/>
-                        </a:defRPr>
-                      </a:pPr>
-                      <a:r>
-                        <a:t>about 40% to 0-6%</a:t>
-                      </a:r>
-                    </a:p>
-                  </a:txBody>
-                  <a:tcPr marL="54864" marR="54864" marT="27432" marB="27432" anchor="ctr"/>
-                </a:tc>
-                <a:tc>
-                  <a:txBody>
-                    <a:bodyPr/>
-                    <a:lstStyle/>
-                    <a:p>
-                      <a:pPr>
-                        <a:lnSpc>
-                          <a:spcPct val="100000"/>
-                        </a:lnSpc>
-                        <a:defRPr sz="1200" b="0">
-                          <a:solidFill>
-                            <a:srgbClr val="000000"/>
-                          </a:solidFill>
-                          <a:latin typeface="Calibri"/>
-                        </a:defRPr>
-                      </a:pPr>
-                      <a:r>
-                        <a:t>n/a</a:t>
-                      </a:r>
-                    </a:p>
-                  </a:txBody>
-                  <a:tcPr marL="54864" marR="54864" marT="27432" marB="27432" anchor="ctr"/>
-                </a:tc>
-                <a:tc>
-                  <a:txBody>
-                    <a:bodyPr/>
-                    <a:lstStyle/>
-                    <a:p>
-                      <a:pPr>
-                        <a:lnSpc>
-                          <a:spcPct val="100000"/>
-                        </a:lnSpc>
-                        <a:defRPr sz="1200" b="0">
-                          <a:solidFill>
-                            <a:srgbClr val="000000"/>
-                          </a:solidFill>
-                          <a:latin typeface="Calibri"/>
-                        </a:defRPr>
-                      </a:pPr>
-                      <a:r>
-                        <a:t>JMIR 2025</a:t>
-                      </a:r>
-                    </a:p>
-                  </a:txBody>
-                  <a:tcPr marL="54864" marR="54864" marT="27432" marB="27432" anchor="ctr"/>
-                </a:tc>
-              </a:tr>
-            </a:tbl>
-          </a:graphicData>
-        </a:graphic>
-      </p:graphicFrame>
-      <p:sp>
-        <p:nvSpPr>
-          <p:cNvPr id="5" name="TextBox 4"/>
+      <p:sp>
+        <p:nvSpPr>
+          <p:cNvPr id="4" name="TextBox 3"/>
           <p:cNvSpPr txBox="1"/>
           <p:nvPr/>
         </p:nvSpPr>
         <p:spPr>
           <a:xfrm>
-            <a:off x="777240" y="4892040"/>
-            <a:ext cx="10698480" cy="1645920"/>
+            <a:off x="777240" y="1600200"/>
+            <a:ext cx="10698480" cy="4937760"/>
           </a:xfrm>
           <a:prstGeom prst="rect">
             <a:avLst/>
@@ -7192,7 +5883,7 @@
               </a:spcAft>
             </a:pPr>
             <a:r>
-              <a:rPr sz="1400">
+              <a:rPr sz="1800">
                 <a:solidFill>
                   <a:srgbClr val="000000"/>
                 </a:solidFill>
@@ -7201,22 +5892,22 @@
               <a:t>•  </a:t>
             </a:r>
             <a:r>
-              <a:rPr sz="1400" b="1">
-                <a:solidFill>
-                  <a:srgbClr val="000000"/>
-                </a:solidFill>
-                <a:latin typeface="Calibri"/>
-              </a:rPr>
-              <a:t>Hallucination = confident wrong:</a:t>
-            </a:r>
-            <a:r>
-              <a:rPr sz="1400" b="0">
-                <a:solidFill>
-                  <a:srgbClr val="000000"/>
-                </a:solidFill>
-                <a:latin typeface="Calibri"/>
-              </a:rPr>
-              <a:t> wrong verdicts among the answers the system commits to (abstentions are not hallucinations).</a:t>
+              <a:rPr sz="1800" b="1">
+                <a:solidFill>
+                  <a:srgbClr val="000000"/>
+                </a:solidFill>
+                <a:latin typeface="Calibri"/>
+              </a:rPr>
+              <a:t>Runs locally</a:t>
+            </a:r>
+            <a:r>
+              <a:rPr sz="1800" b="0">
+                <a:solidFill>
+                  <a:srgbClr val="000000"/>
+                </a:solidFill>
+                <a:latin typeface="Calibri"/>
+              </a:rPr>
+              <a:t> with qwen2.5:7b via Ollama, fully offline-capable; ~8 seconds per claim.</a:t>
             </a:r>
           </a:p>
           <a:p>
@@ -7229,7 +5920,7 @@
               </a:spcAft>
             </a:pPr>
             <a:r>
-              <a:rPr sz="1400">
+              <a:rPr sz="1800">
                 <a:solidFill>
                   <a:srgbClr val="000000"/>
                 </a:solidFill>
@@ -7238,22 +5929,22 @@
               <a:t>•  </a:t>
             </a:r>
             <a:r>
-              <a:rPr sz="1400" b="1">
-                <a:solidFill>
-                  <a:srgbClr val="000000"/>
-                </a:solidFill>
-                <a:latin typeface="Calibri"/>
-              </a:rPr>
-              <a:t>Result:</a:t>
-            </a:r>
-            <a:r>
-              <a:rPr sz="1400" b="0">
-                <a:solidFill>
-                  <a:srgbClr val="000000"/>
-                </a:solidFill>
-                <a:latin typeface="Calibri"/>
-              </a:rPr>
-              <a:t> the retrieval-grounded system lowers the confident-wrong rate (43.8% to 33.3%) by abstaining when evidence is weak.</a:t>
+              <a:rPr sz="1800" b="1">
+                <a:solidFill>
+                  <a:srgbClr val="000000"/>
+                </a:solidFill>
+                <a:latin typeface="Calibri"/>
+              </a:rPr>
+              <a:t>Try any claim:</a:t>
+            </a:r>
+            <a:r>
+              <a:rPr sz="1800" b="0">
+                <a:solidFill>
+                  <a:srgbClr val="000000"/>
+                </a:solidFill>
+                <a:latin typeface="Calibri"/>
+              </a:rPr>
+              <a:t> e.g. "Drinking bleach cures COVID-19" -&gt; False; "The MMR vaccine is safe and effective" -&gt; True.</a:t>
             </a:r>
           </a:p>
           <a:p>
@@ -7266,7 +5957,7 @@
               </a:spcAft>
             </a:pPr>
             <a:r>
-              <a:rPr sz="1400">
+              <a:rPr sz="1800">
                 <a:solidFill>
                   <a:srgbClr val="000000"/>
                 </a:solidFill>
@@ -7275,172 +5966,63 @@
               <a:t>•  </a:t>
             </a:r>
             <a:r>
-              <a:rPr sz="1400" b="1">
-                <a:solidFill>
-                  <a:srgbClr val="000000"/>
-                </a:solidFill>
-                <a:latin typeface="Calibri"/>
-              </a:rPr>
-              <a:t>Caveat:</a:t>
-            </a:r>
-            <a:r>
-              <a:rPr sz="1400" b="0">
-                <a:solidFill>
-                  <a:srgbClr val="000000"/>
-                </a:solidFill>
-                <a:latin typeface="Calibri"/>
-              </a:rPr>
-              <a:t> 30-claim sample and a 7B local model; the published RAG study shows the same direction more strongly.</a:t>
-            </a:r>
-          </a:p>
-        </p:txBody>
-      </p:sp>
-    </p:spTree>
-  </p:cSld>
-  <p:clrMapOvr>
-    <a:masterClrMapping/>
-  </p:clrMapOvr>
-</p:sld>
-</file>
-
-<file path=ppt/slides/slide9.xml><?xml version="1.0" encoding="utf-8"?>
-<p:sld xmlns:a="http://schemas.openxmlformats.org/drawingml/2006/main" xmlns:p="http://schemas.openxmlformats.org/presentationml/2006/main" xmlns:r="http://schemas.openxmlformats.org/officeDocument/2006/relationships">
-  <p:cSld>
-    <p:spTree>
-      <p:nvGrpSpPr>
-        <p:cNvPr id="1" name=""/>
-        <p:cNvGrpSpPr/>
-        <p:nvPr/>
-      </p:nvGrpSpPr>
-      <p:grpSpPr/>
-      <p:sp>
-        <p:nvSpPr>
-          <p:cNvPr id="2" name="TextBox 1"/>
-          <p:cNvSpPr txBox="1"/>
-          <p:nvPr/>
-        </p:nvSpPr>
-        <p:spPr>
-          <a:xfrm>
-            <a:off x="640080" y="347472"/>
-            <a:ext cx="10927080" cy="914400"/>
-          </a:xfrm>
-          <a:prstGeom prst="rect">
-            <a:avLst/>
-          </a:prstGeom>
-          <a:noFill/>
-        </p:spPr>
-        <p:txBody>
-          <a:bodyPr wrap="square">
-            <a:spAutoFit/>
-          </a:bodyPr>
-          <a:lstStyle/>
+              <a:rPr sz="1800" b="1">
+                <a:solidFill>
+                  <a:srgbClr val="000000"/>
+                </a:solidFill>
+                <a:latin typeface="Calibri"/>
+              </a:rPr>
+              <a:t>Usability:</a:t>
+            </a:r>
+            <a:r>
+              <a:rPr sz="1800" b="0">
+                <a:solidFill>
+                  <a:srgbClr val="000000"/>
+                </a:solidFill>
+                <a:latin typeface="Calibri"/>
+              </a:rPr>
+              <a:t> press Enter to submit; each knowledge graph has a maximize/fullscreen button.</a:t>
+            </a:r>
+          </a:p>
           <a:p>
             <a:pPr>
-              <a:defRPr sz="3200" b="1">
-                <a:solidFill>
-                  <a:srgbClr val="1F1F1F"/>
-                </a:solidFill>
-                <a:latin typeface="Calibri"/>
-              </a:defRPr>
+              <a:lnSpc>
+                <a:spcPct val="108000"/>
+              </a:lnSpc>
+              <a:spcAft>
+                <a:spcPts val="1000"/>
+              </a:spcAft>
             </a:pPr>
             <a:r>
-              <a:t>Implementation (Live)</a:t>
-            </a:r>
-          </a:p>
-        </p:txBody>
-      </p:sp>
-      <p:sp>
-        <p:nvSpPr>
-          <p:cNvPr id="3" name="Rectangle 2"/>
-          <p:cNvSpPr/>
-          <p:nvPr/>
-        </p:nvSpPr>
-        <p:spPr>
-          <a:xfrm>
-            <a:off x="640080" y="1298448"/>
-            <a:ext cx="10927080" cy="17780"/>
-          </a:xfrm>
-          <a:prstGeom prst="rect">
-            <a:avLst/>
-          </a:prstGeom>
-          <a:solidFill>
-            <a:srgbClr val="BFBFBF"/>
-          </a:solidFill>
-          <a:ln>
-            <a:noFill/>
-          </a:ln>
-          <a:effectLst/>
-        </p:spPr>
-        <p:style>
-          <a:lnRef idx="1">
-            <a:schemeClr val="accent1"/>
-          </a:lnRef>
-          <a:fillRef idx="3">
-            <a:schemeClr val="accent1"/>
-          </a:fillRef>
-          <a:effectRef idx="2">
-            <a:schemeClr val="accent1"/>
-          </a:effectRef>
-          <a:fontRef idx="minor">
-            <a:schemeClr val="lt1"/>
-          </a:fontRef>
-        </p:style>
-        <p:txBody>
-          <a:bodyPr rtlCol="0" anchor="ctr"/>
-          <a:lstStyle/>
-          <a:p>
-            <a:pPr algn="ctr"/>
-          </a:p>
-        </p:txBody>
-      </p:sp>
-      <p:pic>
-        <p:nvPicPr>
-          <p:cNvPr id="4" name="Picture 3" descr="result_app.png"/>
-          <p:cNvPicPr>
-            <a:picLocks noChangeAspect="1"/>
-          </p:cNvPicPr>
-          <p:nvPr/>
-        </p:nvPicPr>
-        <p:blipFill>
-          <a:blip r:embed="rId2"/>
-          <a:stretch>
-            <a:fillRect/>
-          </a:stretch>
-        </p:blipFill>
-        <p:spPr>
-          <a:xfrm>
-            <a:off x="457200" y="1554480"/>
-            <a:ext cx="6858000" cy="3466890"/>
-          </a:xfrm>
-          <a:prstGeom prst="rect">
-            <a:avLst/>
-          </a:prstGeom>
-        </p:spPr>
-      </p:pic>
-      <p:pic>
-        <p:nvPicPr>
-          <p:cNvPr id="5" name="Picture 4" descr="landing.png"/>
-          <p:cNvPicPr>
-            <a:picLocks noChangeAspect="1"/>
-          </p:cNvPicPr>
-          <p:nvPr/>
-        </p:nvPicPr>
-        <p:blipFill>
-          <a:blip r:embed="rId3"/>
-          <a:stretch>
-            <a:fillRect/>
-          </a:stretch>
-        </p:blipFill>
-        <p:spPr>
-          <a:xfrm>
-            <a:off x="7498079" y="1554480"/>
-            <a:ext cx="4206240" cy="2126359"/>
-          </a:xfrm>
-          <a:prstGeom prst="rect">
-            <a:avLst/>
-          </a:prstGeom>
-        </p:spPr>
-      </p:pic>
+              <a:rPr sz="1800">
+                <a:solidFill>
+                  <a:srgbClr val="000000"/>
+                </a:solidFill>
+                <a:latin typeface="Calibri"/>
+              </a:rPr>
+              <a:t>•  </a:t>
+            </a:r>
+            <a:r>
+              <a:rPr sz="1800" b="1">
+                <a:solidFill>
+                  <a:srgbClr val="000000"/>
+                </a:solidFill>
+                <a:latin typeface="Calibri"/>
+              </a:rPr>
+              <a:t>Future work:</a:t>
+            </a:r>
+            <a:r>
+              <a:rPr sz="1800" b="0">
+                <a:solidFill>
+                  <a:srgbClr val="000000"/>
+                </a:solidFill>
+                <a:latin typeface="Calibri"/>
+              </a:rPr>
+              <a:t> ingest DBpedia health triples, add multi-step reasoning, calibrate the judge, and report confidence intervals on a larger set.</a:t>
+            </a:r>
+          </a:p>
+        </p:txBody>
+      </p:sp>
     </p:spTree>
   </p:cSld>
   <p:clrMapOvr>

</xml_diff>